<commit_message>
Introduce layout variations (3-column, horizontal stacks, flipped cards), simplify gate and temperature formulas, and add Shiva Gupta to Group 3
</commit_message>
<xml_diff>
--- a/presentation.pptx
+++ b/presentation.pptx
@@ -3118,7 +3118,7 @@
         </p:nvSpPr>
         <p:spPr>
           <a:xfrm>
-            <a:off x="731520" y="1645920"/>
+            <a:off x="731520" y="1463040"/>
             <a:ext cx="10728655" cy="1645920"/>
           </a:xfrm>
           <a:prstGeom prst="rect">
@@ -3139,7 +3139,7 @@
               <a:spcAft>
                 <a:spcPts val="600"/>
               </a:spcAft>
-              <a:defRPr sz="3800" b="1" i="0">
+              <a:defRPr sz="3600" b="1" i="0">
                 <a:solidFill>
                   <a:srgbClr val="FBBF24"/>
                 </a:solidFill>
@@ -3166,7 +3166,7 @@
               </a:defRPr>
             </a:pPr>
             <a:r>
-              <a:t>Comparative Analysis of Batch Normalization &amp; Character-Level LSTMs</a:t>
+              <a:t>Comparative Analysis of Batch Normalization &amp; LSTMs</a:t>
             </a:r>
           </a:p>
         </p:txBody>
@@ -3179,7 +3179,7 @@
         </p:nvSpPr>
         <p:spPr>
           <a:xfrm>
-            <a:off x="1371600" y="4114800"/>
+            <a:off x="1371600" y="3931920"/>
             <a:ext cx="9448495" cy="18288"/>
           </a:xfrm>
           <a:prstGeom prst="rect">
@@ -3222,8 +3222,8 @@
         </p:nvSpPr>
         <p:spPr>
           <a:xfrm>
-            <a:off x="1371600" y="4389120"/>
-            <a:ext cx="4572000" cy="2011680"/>
+            <a:off x="1371600" y="4206240"/>
+            <a:ext cx="4572000" cy="2194560"/>
           </a:xfrm>
           <a:prstGeom prst="rect">
             <a:avLst/>
@@ -3241,9 +3241,9 @@
                 <a:spcPct val="115000"/>
               </a:lnSpc>
               <a:spcAft>
-                <a:spcPts val="200"/>
-              </a:spcAft>
-              <a:defRPr sz="1400" b="1" i="0">
+                <a:spcPts val="100"/>
+              </a:spcAft>
+              <a:defRPr sz="1300" b="1" i="0">
                 <a:solidFill>
                   <a:srgbClr val="FFFFFF"/>
                 </a:solidFill>
@@ -3260,9 +3260,9 @@
                 <a:spcPct val="115000"/>
               </a:lnSpc>
               <a:spcAft>
-                <a:spcPts val="1200"/>
-              </a:spcAft>
-              <a:defRPr sz="1200" b="0" i="0">
+                <a:spcPts val="600"/>
+              </a:spcAft>
+              <a:defRPr sz="1000" b="0" i="0">
                 <a:solidFill>
                   <a:srgbClr val="94A3B8"/>
                 </a:solidFill>
@@ -3279,9 +3279,9 @@
                 <a:spcPct val="115000"/>
               </a:lnSpc>
               <a:spcAft>
-                <a:spcPts val="200"/>
-              </a:spcAft>
-              <a:defRPr sz="1400" b="1" i="0">
+                <a:spcPts val="100"/>
+              </a:spcAft>
+              <a:defRPr sz="1300" b="1" i="0">
                 <a:solidFill>
                   <a:srgbClr val="FFFFFF"/>
                 </a:solidFill>
@@ -3298,9 +3298,9 @@
                 <a:spcPct val="115000"/>
               </a:lnSpc>
               <a:spcAft>
-                <a:spcPts val="1200"/>
-              </a:spcAft>
-              <a:defRPr sz="1200" b="0" i="0">
+                <a:spcPts val="600"/>
+              </a:spcAft>
+              <a:defRPr sz="1000" b="0" i="0">
                 <a:solidFill>
                   <a:srgbClr val="94A3B8"/>
                 </a:solidFill>
@@ -3317,9 +3317,9 @@
                 <a:spcPct val="115000"/>
               </a:lnSpc>
               <a:spcAft>
-                <a:spcPts val="200"/>
-              </a:spcAft>
-              <a:defRPr sz="1400" b="1" i="0">
+                <a:spcPts val="100"/>
+              </a:spcAft>
+              <a:defRPr sz="1300" b="1" i="0">
                 <a:solidFill>
                   <a:srgbClr val="FFFFFF"/>
                 </a:solidFill>
@@ -3338,7 +3338,7 @@
               <a:spcAft>
                 <a:spcPts val="600"/>
               </a:spcAft>
-              <a:defRPr sz="1200" b="0" i="0">
+              <a:defRPr sz="1000" b="0" i="0">
                 <a:solidFill>
                   <a:srgbClr val="94A3B8"/>
                 </a:solidFill>
@@ -3347,6 +3347,44 @@
             </a:pPr>
             <a:r>
               <a:t>Sumit.24bcs10158@sst.scaler.com</a:t>
+            </a:r>
+          </a:p>
+          <a:p>
+            <a:pPr>
+              <a:lnSpc>
+                <a:spcPct val="115000"/>
+              </a:lnSpc>
+              <a:spcAft>
+                <a:spcPts val="100"/>
+              </a:spcAft>
+              <a:defRPr sz="1300" b="1" i="0">
+                <a:solidFill>
+                  <a:srgbClr val="FFFFFF"/>
+                </a:solidFill>
+                <a:latin typeface="Georgia"/>
+              </a:defRPr>
+            </a:pPr>
+            <a:r>
+              <a:t>Shiva Gupta</a:t>
+            </a:r>
+          </a:p>
+          <a:p>
+            <a:pPr>
+              <a:lnSpc>
+                <a:spcPct val="115000"/>
+              </a:lnSpc>
+              <a:spcAft>
+                <a:spcPts val="600"/>
+              </a:spcAft>
+              <a:defRPr sz="1000" b="0" i="0">
+                <a:solidFill>
+                  <a:srgbClr val="94A3B8"/>
+                </a:solidFill>
+                <a:latin typeface="Calibri"/>
+              </a:defRPr>
+            </a:pPr>
+            <a:r>
+              <a:t>shiva.24bcs10461@sst.scaler.com</a:t>
             </a:r>
           </a:p>
         </p:txBody>
@@ -3359,8 +3397,8 @@
         </p:nvSpPr>
         <p:spPr>
           <a:xfrm>
-            <a:off x="6217920" y="4389120"/>
-            <a:ext cx="4572000" cy="2011680"/>
+            <a:off x="6217920" y="4206240"/>
+            <a:ext cx="4572000" cy="2194560"/>
           </a:xfrm>
           <a:prstGeom prst="rect">
             <a:avLst/>
@@ -3378,9 +3416,9 @@
                 <a:spcPct val="115000"/>
               </a:lnSpc>
               <a:spcAft>
-                <a:spcPts val="200"/>
-              </a:spcAft>
-              <a:defRPr sz="1400" b="1" i="0">
+                <a:spcPts val="100"/>
+              </a:spcAft>
+              <a:defRPr sz="1300" b="1" i="0">
                 <a:solidFill>
                   <a:srgbClr val="FFFFFF"/>
                 </a:solidFill>
@@ -3397,9 +3435,9 @@
                 <a:spcPct val="115000"/>
               </a:lnSpc>
               <a:spcAft>
-                <a:spcPts val="1200"/>
-              </a:spcAft>
-              <a:defRPr sz="1200" b="0" i="0">
+                <a:spcPts val="600"/>
+              </a:spcAft>
+              <a:defRPr sz="1000" b="0" i="0">
                 <a:solidFill>
                   <a:srgbClr val="94A3B8"/>
                 </a:solidFill>
@@ -3416,9 +3454,9 @@
                 <a:spcPct val="115000"/>
               </a:lnSpc>
               <a:spcAft>
-                <a:spcPts val="200"/>
-              </a:spcAft>
-              <a:defRPr sz="1400" b="1" i="0">
+                <a:spcPts val="100"/>
+              </a:spcAft>
+              <a:defRPr sz="1300" b="1" i="0">
                 <a:solidFill>
                   <a:srgbClr val="FFFFFF"/>
                 </a:solidFill>
@@ -3435,9 +3473,9 @@
                 <a:spcPct val="115000"/>
               </a:lnSpc>
               <a:spcAft>
-                <a:spcPts val="1200"/>
-              </a:spcAft>
-              <a:defRPr sz="1200" b="0" i="0">
+                <a:spcPts val="600"/>
+              </a:spcAft>
+              <a:defRPr sz="1000" b="0" i="0">
                 <a:solidFill>
                   <a:srgbClr val="94A3B8"/>
                 </a:solidFill>
@@ -3454,9 +3492,9 @@
                 <a:spcPct val="115000"/>
               </a:lnSpc>
               <a:spcAft>
-                <a:spcPts val="200"/>
-              </a:spcAft>
-              <a:defRPr sz="1400" b="1" i="0">
+                <a:spcPts val="100"/>
+              </a:spcAft>
+              <a:defRPr sz="1300" b="1" i="0">
                 <a:solidFill>
                   <a:srgbClr val="FFFFFF"/>
                 </a:solidFill>
@@ -3475,7 +3513,7 @@
               <a:spcAft>
                 <a:spcPts val="600"/>
               </a:spcAft>
-              <a:defRPr sz="1200" b="0" i="0">
+              <a:defRPr sz="1000" b="0" i="0">
                 <a:solidFill>
                   <a:srgbClr val="94A3B8"/>
                 </a:solidFill>
@@ -3602,6 +3640,75 @@
         <p:spPr>
           <a:xfrm>
             <a:off x="731520" y="1463040"/>
+            <a:ext cx="5608015" cy="4572000"/>
+          </a:xfrm>
+          <a:prstGeom prst="roundRect">
+            <a:avLst/>
+          </a:prstGeom>
+          <a:solidFill>
+            <a:srgbClr val="141B2D"/>
+          </a:solidFill>
+          <a:ln w="19050">
+            <a:solidFill>
+              <a:srgbClr val="B47314"/>
+            </a:solidFill>
+          </a:ln>
+        </p:spPr>
+        <p:style>
+          <a:lnRef idx="1">
+            <a:schemeClr val="accent1"/>
+          </a:lnRef>
+          <a:fillRef idx="3">
+            <a:schemeClr val="accent1"/>
+          </a:fillRef>
+          <a:effectRef idx="2">
+            <a:schemeClr val="accent1"/>
+          </a:effectRef>
+          <a:fontRef idx="minor">
+            <a:schemeClr val="lt1"/>
+          </a:fontRef>
+        </p:style>
+        <p:txBody>
+          <a:bodyPr rtlCol="0" anchor="ctr"/>
+          <a:lstStyle/>
+          <a:p>
+            <a:pPr algn="ctr"/>
+          </a:p>
+        </p:txBody>
+      </p:sp>
+      <p:pic>
+        <p:nvPicPr>
+          <p:cNvPr id="5" name="Picture 4" descr="task2_exp2_high_lr.png"/>
+          <p:cNvPicPr>
+            <a:picLocks noChangeAspect="1"/>
+          </p:cNvPicPr>
+          <p:nvPr/>
+        </p:nvPicPr>
+        <p:blipFill>
+          <a:blip r:embed="rId2"/>
+          <a:stretch>
+            <a:fillRect/>
+          </a:stretch>
+        </p:blipFill>
+        <p:spPr>
+          <a:xfrm>
+            <a:off x="914400" y="1645920"/>
+            <a:ext cx="5242255" cy="4206240"/>
+          </a:xfrm>
+          <a:prstGeom prst="rect">
+            <a:avLst/>
+          </a:prstGeom>
+        </p:spPr>
+      </p:pic>
+      <p:sp>
+        <p:nvSpPr>
+          <p:cNvPr id="6" name="Rounded Rectangle 5"/>
+          <p:cNvSpPr/>
+          <p:nvPr/>
+        </p:nvSpPr>
+        <p:spPr>
+          <a:xfrm>
+            <a:off x="6705295" y="1463040"/>
             <a:ext cx="4754880" cy="4572000"/>
           </a:xfrm>
           <a:prstGeom prst="roundRect">
@@ -3640,13 +3747,13 @@
       </p:sp>
       <p:sp>
         <p:nvSpPr>
-          <p:cNvPr id="5" name="TextBox 4"/>
+          <p:cNvPr id="7" name="TextBox 6"/>
           <p:cNvSpPr txBox="1"/>
           <p:nvPr/>
         </p:nvSpPr>
         <p:spPr>
           <a:xfrm>
-            <a:off x="960120" y="1691640"/>
+            <a:off x="6933895" y="1691640"/>
             <a:ext cx="4297680" cy="4114800"/>
           </a:xfrm>
           <a:prstGeom prst="rect">
@@ -3713,7 +3820,7 @@
               </a:defRPr>
             </a:pPr>
             <a:r>
-              <a:t>  - Learning rate = 0.2, standard initialization, trained for 5 epochs.</a:t>
+              <a:t>  - Learning rate = 0.2 (extremely aggressive), trained for 5 epochs.</a:t>
             </a:r>
           </a:p>
           <a:p>
@@ -3751,7 +3858,7 @@
               </a:defRPr>
             </a:pPr>
             <a:r>
-              <a:t>  - With Batch Norm: Trains stably and converges to 98.24% test accuracy (highest accuracy achieved).</a:t>
+              <a:t>  - With Batch Norm: Extremely stable training, reaching 98.24% test accuracy (best overall score).</a:t>
             </a:r>
           </a:p>
           <a:p>
@@ -3770,7 +3877,7 @@
               </a:defRPr>
             </a:pPr>
             <a:r>
-              <a:t>  - No Batch Norm: Fails completely to learn. Loss flatlines at 2.3026, test accuracy stays at 11.35% (random guessing).</a:t>
+              <a:t>  - No Batch Norm: Fails completely. Weights explode, loss flatlines at 2.3026, and accuracy stays stuck at 11.35% (random guessing).</a:t>
             </a:r>
           </a:p>
           <a:p>
@@ -3808,80 +3915,11 @@
               </a:defRPr>
             </a:pPr>
             <a:r>
-              <a:t>  - Batch Norm scale-invariance stabilizes gradient updates, permitting higher learning rates that accelerate training.</a:t>
-            </a:r>
-          </a:p>
-        </p:txBody>
-      </p:sp>
-      <p:sp>
-        <p:nvSpPr>
-          <p:cNvPr id="6" name="Rounded Rectangle 5"/>
-          <p:cNvSpPr/>
-          <p:nvPr/>
-        </p:nvSpPr>
-        <p:spPr>
-          <a:xfrm>
-            <a:off x="5852160" y="1463040"/>
-            <a:ext cx="5608015" cy="4572000"/>
-          </a:xfrm>
-          <a:prstGeom prst="roundRect">
-            <a:avLst/>
-          </a:prstGeom>
-          <a:solidFill>
-            <a:srgbClr val="141B2D"/>
-          </a:solidFill>
-          <a:ln w="19050">
-            <a:solidFill>
-              <a:srgbClr val="B47314"/>
-            </a:solidFill>
-          </a:ln>
-        </p:spPr>
-        <p:style>
-          <a:lnRef idx="1">
-            <a:schemeClr val="accent1"/>
-          </a:lnRef>
-          <a:fillRef idx="3">
-            <a:schemeClr val="accent1"/>
-          </a:fillRef>
-          <a:effectRef idx="2">
-            <a:schemeClr val="accent1"/>
-          </a:effectRef>
-          <a:fontRef idx="minor">
-            <a:schemeClr val="lt1"/>
-          </a:fontRef>
-        </p:style>
-        <p:txBody>
-          <a:bodyPr rtlCol="0" anchor="ctr"/>
-          <a:lstStyle/>
-          <a:p>
-            <a:pPr algn="ctr"/>
-          </a:p>
-        </p:txBody>
-      </p:sp>
-      <p:pic>
-        <p:nvPicPr>
-          <p:cNvPr id="7" name="Picture 6" descr="task2_exp2_high_lr.png"/>
-          <p:cNvPicPr>
-            <a:picLocks noChangeAspect="1"/>
-          </p:cNvPicPr>
-          <p:nvPr/>
-        </p:nvPicPr>
-        <p:blipFill>
-          <a:blip r:embed="rId2"/>
-          <a:stretch>
-            <a:fillRect/>
-          </a:stretch>
-        </p:blipFill>
-        <p:spPr>
-          <a:xfrm>
-            <a:off x="6035040" y="1645920"/>
-            <a:ext cx="5242255" cy="4206240"/>
-          </a:xfrm>
-          <a:prstGeom prst="rect">
-            <a:avLst/>
-          </a:prstGeom>
-        </p:spPr>
-      </p:pic>
+              <a:t>  - Batch Norm scale-invariance stabilizes gradient updates, allowing the network to train under massive learning rates.</a:t>
+            </a:r>
+          </a:p>
+        </p:txBody>
+      </p:sp>
     </p:spTree>
   </p:cSld>
   <p:clrMapOvr>
@@ -4145,7 +4183,7 @@
               </a:defRPr>
             </a:pPr>
             <a:r>
-              <a:t>  - With Batch Norm: Successfully rescues training, converging to 97.48% test accuracy.</a:t>
+              <a:t>  - With Batch Norm: Successfully rescales weak signals, training to 97.48% test accuracy.</a:t>
             </a:r>
           </a:p>
           <a:p>
@@ -4164,7 +4202,7 @@
               </a:defRPr>
             </a:pPr>
             <a:r>
-              <a:t>  - No Batch Norm: Fails completely. Loss remains stuck at 2.3026, test accuracy stuck at 11.35% (vanishing gradients).</a:t>
+              <a:t>  - No Batch Norm: Fails completely. Signal vanishes through 6 layers; loss stays at 2.3026, test accuracy stuck at 11.35% (vanishing gradients).</a:t>
             </a:r>
           </a:p>
           <a:p>
@@ -4702,7 +4740,7 @@
               </a:defRPr>
             </a:pPr>
             <a:r>
-              <a:t>Why it Stabilizes Gradient Flow</a:t>
+              <a:t>Scale Invariance Intuition</a:t>
             </a:r>
           </a:p>
           <a:p>
@@ -4721,7 +4759,7 @@
               </a:defRPr>
             </a:pPr>
             <a:r>
-              <a:t>• Decoupling Weight scale from Activation scale:</a:t>
+              <a:t>• Mathematical Scale Invariance:</a:t>
             </a:r>
           </a:p>
           <a:p>
@@ -4740,7 +4778,7 @@
               </a:defRPr>
             </a:pPr>
             <a:r>
-              <a:t>  - Dividing by standard deviation ensures activations never shrink to zero or blow up to infinity, regardless of weight magnitudes.</a:t>
+              <a:t>  - Because we divide by the standard deviation, scaling the weights by any factor does not change the output of the normalization layer. This stabilizes gradient flow.</a:t>
             </a:r>
           </a:p>
           <a:p>
@@ -5183,7 +5221,7 @@
                         </a:defRPr>
                       </a:pPr>
                       <a:r>
-                        <a:t>97.10% (Accelerated)</a:t>
+                        <a:t>97.10% (Trained)</a:t>
                       </a:r>
                     </a:p>
                   </a:txBody>
@@ -5305,7 +5343,7 @@
                         </a:defRPr>
                       </a:pPr>
                       <a:r>
-                        <a:t>98.24% (Stable)</a:t>
+                        <a:t>98.24% (Trained)</a:t>
                       </a:r>
                     </a:p>
                   </a:txBody>
@@ -5427,7 +5465,7 @@
                         </a:defRPr>
                       </a:pPr>
                       <a:r>
-                        <a:t>97.48% (Rescued)</a:t>
+                        <a:t>97.48% (Trained)</a:t>
                       </a:r>
                     </a:p>
                   </a:txBody>
@@ -5617,7 +5655,7 @@
         <p:spPr>
           <a:xfrm>
             <a:off x="731520" y="1463040"/>
-            <a:ext cx="5120640" cy="4572000"/>
+            <a:ext cx="10728655" cy="1280160"/>
           </a:xfrm>
           <a:prstGeom prst="roundRect">
             <a:avLst/>
@@ -5661,8 +5699,8 @@
         </p:nvSpPr>
         <p:spPr>
           <a:xfrm>
-            <a:off x="960120" y="1691640"/>
-            <a:ext cx="4663440" cy="4114800"/>
+            <a:off x="960120" y="1554480"/>
+            <a:ext cx="10271455" cy="1097280"/>
           </a:xfrm>
           <a:prstGeom prst="rect">
             <a:avLst/>
@@ -5680,9 +5718,9 @@
                 <a:spcPct val="115000"/>
               </a:lnSpc>
               <a:spcAft>
-                <a:spcPts val="1200"/>
-              </a:spcAft>
-              <a:defRPr sz="1800" b="1" i="0">
+                <a:spcPts val="200"/>
+              </a:spcAft>
+              <a:defRPr sz="1400" b="1" i="0">
                 <a:solidFill>
                   <a:srgbClr val="FBBF24"/>
                 </a:solidFill>
@@ -5690,83 +5728,26 @@
               </a:defRPr>
             </a:pPr>
             <a:r>
-              <a:t>Universal Approximation &amp; Initialization</a:t>
-            </a:r>
-          </a:p>
-          <a:p>
-            <a:pPr>
-              <a:lnSpc>
-                <a:spcPct val="115000"/>
-              </a:lnSpc>
-              <a:spcAft>
-                <a:spcPts val="200"/>
-              </a:spcAft>
-              <a:defRPr sz="1400" b="1" i="0">
-                <a:solidFill>
-                  <a:srgbClr val="FFFFFF"/>
+              <a:t>• Representation Learning:</a:t>
+            </a:r>
+          </a:p>
+          <a:p>
+            <a:pPr>
+              <a:lnSpc>
+                <a:spcPct val="115000"/>
+              </a:lnSpc>
+              <a:spcAft>
+                <a:spcPts val="600"/>
+              </a:spcAft>
+              <a:defRPr sz="1300" b="0" i="0">
+                <a:solidFill>
+                  <a:srgbClr val="D1D5DB"/>
                 </a:solidFill>
                 <a:latin typeface="Calibri"/>
               </a:defRPr>
             </a:pPr>
             <a:r>
-              <a:t>• Universal Approximation Theorem:</a:t>
-            </a:r>
-          </a:p>
-          <a:p>
-            <a:pPr>
-              <a:lnSpc>
-                <a:spcPct val="115000"/>
-              </a:lnSpc>
-              <a:spcAft>
-                <a:spcPts val="1600"/>
-              </a:spcAft>
-              <a:defRPr sz="1200" b="0" i="0">
-                <a:solidFill>
-                  <a:srgbClr val="D1D5DB"/>
-                </a:solidFill>
-                <a:latin typeface="Calibri"/>
-              </a:defRPr>
-            </a:pPr>
-            <a:r>
-              <a:t>  - Standard deep feedforward networks and Recurrent structures can approximate arbitrary complex non-linear mappings. Character-level LSTMs utilize this representation capacity to discover language syntax dynamically from character context.</a:t>
-            </a:r>
-          </a:p>
-          <a:p>
-            <a:pPr>
-              <a:lnSpc>
-                <a:spcPct val="115000"/>
-              </a:lnSpc>
-              <a:spcAft>
-                <a:spcPts val="200"/>
-              </a:spcAft>
-              <a:defRPr sz="1400" b="1" i="0">
-                <a:solidFill>
-                  <a:srgbClr val="FFFFFF"/>
-                </a:solidFill>
-                <a:latin typeface="Calibri"/>
-              </a:defRPr>
-            </a:pPr>
-            <a:r>
-              <a:t>• Weight Initialization (Xavier / He):</a:t>
-            </a:r>
-          </a:p>
-          <a:p>
-            <a:pPr>
-              <a:lnSpc>
-                <a:spcPct val="115000"/>
-              </a:lnSpc>
-              <a:spcAft>
-                <a:spcPts val="600"/>
-              </a:spcAft>
-              <a:defRPr sz="1200" b="0" i="0">
-                <a:solidFill>
-                  <a:srgbClr val="D1D5DB"/>
-                </a:solidFill>
-                <a:latin typeface="Calibri"/>
-              </a:defRPr>
-            </a:pPr>
-            <a:r>
-              <a:t>  - Proper initialization (e.g. He initialization for ReLU) is critical to prevent activation variance from vanishing or exploding in deep layers. Batch Norm relaxes this structural requirement by dynamically rescaling the variance at every layer.</a:t>
+              <a:t>  Character-level LSTMs automatically discover complex spelling, grammar, and language patterns directly from raw sequences without manual, hard-coded rules.</a:t>
             </a:r>
           </a:p>
         </p:txBody>
@@ -5779,8 +5760,8 @@
         </p:nvSpPr>
         <p:spPr>
           <a:xfrm>
-            <a:off x="6339535" y="1463040"/>
-            <a:ext cx="5120640" cy="4572000"/>
+            <a:off x="731520" y="2926080"/>
+            <a:ext cx="10728655" cy="1280160"/>
           </a:xfrm>
           <a:prstGeom prst="roundRect">
             <a:avLst/>
@@ -5824,8 +5805,8 @@
         </p:nvSpPr>
         <p:spPr>
           <a:xfrm>
-            <a:off x="6568135" y="1691640"/>
-            <a:ext cx="4663440" cy="4114800"/>
+            <a:off x="960120" y="3017520"/>
+            <a:ext cx="10271455" cy="1097280"/>
           </a:xfrm>
           <a:prstGeom prst="rect">
             <a:avLst/>
@@ -5843,9 +5824,9 @@
                 <a:spcPct val="115000"/>
               </a:lnSpc>
               <a:spcAft>
-                <a:spcPts val="1200"/>
-              </a:spcAft>
-              <a:defRPr sz="1800" b="1" i="0">
+                <a:spcPts val="200"/>
+              </a:spcAft>
+              <a:defRPr sz="1400" b="1" i="0">
                 <a:solidFill>
                   <a:srgbClr val="FBBF24"/>
                 </a:solidFill>
@@ -5853,9 +5834,96 @@
               </a:defRPr>
             </a:pPr>
             <a:r>
-              <a:t>Optimization Dynamics &amp; Regularization</a:t>
-            </a:r>
-          </a:p>
+              <a:t>• Weight Initialization Dynamics:</a:t>
+            </a:r>
+          </a:p>
+          <a:p>
+            <a:pPr>
+              <a:lnSpc>
+                <a:spcPct val="115000"/>
+              </a:lnSpc>
+              <a:spcAft>
+                <a:spcPts val="600"/>
+              </a:spcAft>
+              <a:defRPr sz="1300" b="0" i="0">
+                <a:solidFill>
+                  <a:srgbClr val="D1D5DB"/>
+                </a:solidFill>
+                <a:latin typeface="Calibri"/>
+              </a:defRPr>
+            </a:pPr>
+            <a:r>
+              <a:t>  Kaiming initialization works well under normal conditions, but is highly sensitive to depth. Batch Norm relaxes this scale dependency by dynamically adjusting variance.</a:t>
+            </a:r>
+          </a:p>
+        </p:txBody>
+      </p:sp>
+      <p:sp>
+        <p:nvSpPr>
+          <p:cNvPr id="8" name="Rounded Rectangle 7"/>
+          <p:cNvSpPr/>
+          <p:nvPr/>
+        </p:nvSpPr>
+        <p:spPr>
+          <a:xfrm>
+            <a:off x="731520" y="4389120"/>
+            <a:ext cx="10728655" cy="1280160"/>
+          </a:xfrm>
+          <a:prstGeom prst="roundRect">
+            <a:avLst/>
+          </a:prstGeom>
+          <a:solidFill>
+            <a:srgbClr val="141B2D"/>
+          </a:solidFill>
+          <a:ln w="19050">
+            <a:solidFill>
+              <a:srgbClr val="28324B"/>
+            </a:solidFill>
+          </a:ln>
+        </p:spPr>
+        <p:style>
+          <a:lnRef idx="1">
+            <a:schemeClr val="accent1"/>
+          </a:lnRef>
+          <a:fillRef idx="3">
+            <a:schemeClr val="accent1"/>
+          </a:fillRef>
+          <a:effectRef idx="2">
+            <a:schemeClr val="accent1"/>
+          </a:effectRef>
+          <a:fontRef idx="minor">
+            <a:schemeClr val="lt1"/>
+          </a:fontRef>
+        </p:style>
+        <p:txBody>
+          <a:bodyPr rtlCol="0" anchor="ctr"/>
+          <a:lstStyle/>
+          <a:p>
+            <a:pPr algn="ctr"/>
+          </a:p>
+        </p:txBody>
+      </p:sp>
+      <p:sp>
+        <p:nvSpPr>
+          <p:cNvPr id="9" name="TextBox 8"/>
+          <p:cNvSpPr txBox="1"/>
+          <p:nvPr/>
+        </p:nvSpPr>
+        <p:spPr>
+          <a:xfrm>
+            <a:off x="960120" y="4480560"/>
+            <a:ext cx="10271455" cy="1097280"/>
+          </a:xfrm>
+          <a:prstGeom prst="rect">
+            <a:avLst/>
+          </a:prstGeom>
+          <a:noFill/>
+        </p:spPr>
+        <p:txBody>
+          <a:bodyPr wrap="square">
+            <a:spAutoFit/>
+          </a:bodyPr>
+          <a:lstStyle/>
           <a:p>
             <a:pPr>
               <a:lnSpc>
@@ -5866,70 +5934,32 @@
               </a:spcAft>
               <a:defRPr sz="1400" b="1" i="0">
                 <a:solidFill>
-                  <a:srgbClr val="FFFFFF"/>
+                  <a:srgbClr val="FBBF24"/>
+                </a:solidFill>
+                <a:latin typeface="Georgia"/>
+              </a:defRPr>
+            </a:pPr>
+            <a:r>
+              <a:t>• Optimization landscapes:</a:t>
+            </a:r>
+          </a:p>
+          <a:p>
+            <a:pPr>
+              <a:lnSpc>
+                <a:spcPct val="115000"/>
+              </a:lnSpc>
+              <a:spcAft>
+                <a:spcPts val="600"/>
+              </a:spcAft>
+              <a:defRPr sz="1300" b="0" i="0">
+                <a:solidFill>
+                  <a:srgbClr val="D1D5DB"/>
                 </a:solidFill>
                 <a:latin typeface="Calibri"/>
               </a:defRPr>
             </a:pPr>
             <a:r>
-              <a:t>• Optimization Landscapes:</a:t>
-            </a:r>
-          </a:p>
-          <a:p>
-            <a:pPr>
-              <a:lnSpc>
-                <a:spcPct val="115000"/>
-              </a:lnSpc>
-              <a:spcAft>
-                <a:spcPts val="1600"/>
-              </a:spcAft>
-              <a:defRPr sz="1200" b="0" i="0">
-                <a:solidFill>
-                  <a:srgbClr val="D1D5DB"/>
-                </a:solidFill>
-                <a:latin typeface="Calibri"/>
-              </a:defRPr>
-            </a:pPr>
-            <a:r>
-              <a:t>  - High learning rates cause gradient updates to overshoot local minima and diverge. Batch Norm smoothens the optimization landscape, preventing gradients from exploding and making optimization highly stable.</a:t>
-            </a:r>
-          </a:p>
-          <a:p>
-            <a:pPr>
-              <a:lnSpc>
-                <a:spcPct val="115000"/>
-              </a:lnSpc>
-              <a:spcAft>
-                <a:spcPts val="200"/>
-              </a:spcAft>
-              <a:defRPr sz="1400" b="1" i="0">
-                <a:solidFill>
-                  <a:srgbClr val="FFFFFF"/>
-                </a:solidFill>
-                <a:latin typeface="Calibri"/>
-              </a:defRPr>
-            </a:pPr>
-            <a:r>
-              <a:t>• Implicit Regularization:</a:t>
-            </a:r>
-          </a:p>
-          <a:p>
-            <a:pPr>
-              <a:lnSpc>
-                <a:spcPct val="115000"/>
-              </a:lnSpc>
-              <a:spcAft>
-                <a:spcPts val="600"/>
-              </a:spcAft>
-              <a:defRPr sz="1200" b="0" i="0">
-                <a:solidFill>
-                  <a:srgbClr val="D1D5DB"/>
-                </a:solidFill>
-                <a:latin typeface="Calibri"/>
-              </a:defRPr>
-            </a:pPr>
-            <a:r>
-              <a:t>  - The calculation of mean and variance over finite mini-batches introduces moderate stochastic noise into layer activations. This noise acts as a regularizer, reducing overfitting similar to Dropout.</a:t>
+              <a:t>  Deep backpropagation requires gradient stability. Batch Norm smoothens the loss landscape, preventing gradient explosion and allowing for higher learning rates.</a:t>
             </a:r>
           </a:p>
         </p:txBody>
@@ -6140,7 +6170,7 @@
               </a:defRPr>
             </a:pPr>
             <a:r>
-              <a:t>• Sequence Modeling with LSTMs:</a:t>
+              <a:t>• Task 1 Sequence Modeling:</a:t>
             </a:r>
           </a:p>
           <a:p>
@@ -6159,7 +6189,7 @@
               </a:defRPr>
             </a:pPr>
             <a:r>
-              <a:t>  - Stacked LSTMs can successfully learn the structural, orthographical, and grammatical rules of natural text entirely from character sequences without pre-defined vocabularies.</a:t>
+              <a:t>  - Character-level LSTMs successfully capture the structural, orthographical, and grammatical nuances of different corpuses.</a:t>
             </a:r>
           </a:p>
           <a:p>
@@ -6178,7 +6208,7 @@
               </a:defRPr>
             </a:pPr>
             <a:r>
-              <a:t>• Activation Normalization with Batch Norm:</a:t>
+              <a:t>• Task 2 Normalization:</a:t>
             </a:r>
           </a:p>
           <a:p>
@@ -6197,7 +6227,7 @@
               </a:defRPr>
             </a:pPr>
             <a:r>
-              <a:t>  - Batch Normalization is a critical architectural element that stabilizes training, accelerates convergence, and provides extreme robustness to learning rates and initialization scales.</a:t>
+              <a:t>  - Batch Normalization is a critical architectural component for deep networks, providing optimization speedup and stability under stress.</a:t>
             </a:r>
           </a:p>
         </p:txBody>
@@ -6274,7 +6304,7 @@
                 <a:spcPct val="115000"/>
               </a:lnSpc>
               <a:spcAft>
-                <a:spcPts val="1600"/>
+                <a:spcPts val="1200"/>
               </a:spcAft>
               <a:defRPr sz="2200" b="1" i="0">
                 <a:solidFill>
@@ -6293,9 +6323,9 @@
                 <a:spcPct val="115000"/>
               </a:lnSpc>
               <a:spcAft>
-                <a:spcPts val="800"/>
-              </a:spcAft>
-              <a:defRPr sz="1400" b="1" i="0">
+                <a:spcPts val="1400"/>
+              </a:spcAft>
+              <a:defRPr sz="1400" b="0" i="1">
                 <a:solidFill>
                   <a:srgbClr val="FFFFFF"/>
                 </a:solidFill>
@@ -6303,18 +6333,37 @@
               </a:defRPr>
             </a:pPr>
             <a:r>
-              <a:t>Presenters Panel:</a:t>
-            </a:r>
-          </a:p>
-          <a:p>
-            <a:pPr>
-              <a:lnSpc>
-                <a:spcPct val="115000"/>
-              </a:lnSpc>
-              <a:spcAft>
-                <a:spcPts val="400"/>
-              </a:spcAft>
-              <a:defRPr sz="1300" b="0" i="0">
+              <a:t>We are ready for your questions, Sir.</a:t>
+            </a:r>
+          </a:p>
+          <a:p>
+            <a:pPr>
+              <a:lnSpc>
+                <a:spcPct val="115000"/>
+              </a:lnSpc>
+              <a:spcAft>
+                <a:spcPts val="600"/>
+              </a:spcAft>
+              <a:defRPr sz="1300" b="1" i="0">
+                <a:solidFill>
+                  <a:srgbClr val="FFFFFF"/>
+                </a:solidFill>
+                <a:latin typeface="Calibri"/>
+              </a:defRPr>
+            </a:pPr>
+            <a:r>
+              <a:t>Presenters Panel (Group 3):</a:t>
+            </a:r>
+          </a:p>
+          <a:p>
+            <a:pPr>
+              <a:lnSpc>
+                <a:spcPct val="115000"/>
+              </a:lnSpc>
+              <a:spcAft>
+                <a:spcPts val="300"/>
+              </a:spcAft>
+              <a:defRPr sz="1200" b="0" i="0">
                 <a:solidFill>
                   <a:srgbClr val="D1D5DB"/>
                 </a:solidFill>
@@ -6331,9 +6380,9 @@
                 <a:spcPct val="115000"/>
               </a:lnSpc>
               <a:spcAft>
-                <a:spcPts val="400"/>
-              </a:spcAft>
-              <a:defRPr sz="1300" b="0" i="0">
+                <a:spcPts val="300"/>
+              </a:spcAft>
+              <a:defRPr sz="1200" b="0" i="0">
                 <a:solidFill>
                   <a:srgbClr val="D1D5DB"/>
                 </a:solidFill>
@@ -6350,9 +6399,9 @@
                 <a:spcPct val="115000"/>
               </a:lnSpc>
               <a:spcAft>
-                <a:spcPts val="400"/>
-              </a:spcAft>
-              <a:defRPr sz="1300" b="0" i="0">
+                <a:spcPts val="300"/>
+              </a:spcAft>
+              <a:defRPr sz="1200" b="0" i="0">
                 <a:solidFill>
                   <a:srgbClr val="D1D5DB"/>
                 </a:solidFill>
@@ -6369,9 +6418,9 @@
                 <a:spcPct val="115000"/>
               </a:lnSpc>
               <a:spcAft>
-                <a:spcPts val="400"/>
-              </a:spcAft>
-              <a:defRPr sz="1300" b="0" i="0">
+                <a:spcPts val="300"/>
+              </a:spcAft>
+              <a:defRPr sz="1200" b="0" i="0">
                 <a:solidFill>
                   <a:srgbClr val="D1D5DB"/>
                 </a:solidFill>
@@ -6379,6 +6428,25 @@
               </a:defRPr>
             </a:pPr>
             <a:r>
+              <a:t>  • Shiva Gupta</a:t>
+            </a:r>
+          </a:p>
+          <a:p>
+            <a:pPr>
+              <a:lnSpc>
+                <a:spcPct val="115000"/>
+              </a:lnSpc>
+              <a:spcAft>
+                <a:spcPts val="300"/>
+              </a:spcAft>
+              <a:defRPr sz="1200" b="0" i="0">
+                <a:solidFill>
+                  <a:srgbClr val="D1D5DB"/>
+                </a:solidFill>
+                <a:latin typeface="Calibri"/>
+              </a:defRPr>
+            </a:pPr>
+            <a:r>
               <a:t>  • Sarthak Mishra</a:t>
             </a:r>
           </a:p>
@@ -6388,9 +6456,9 @@
                 <a:spcPct val="115000"/>
               </a:lnSpc>
               <a:spcAft>
-                <a:spcPts val="400"/>
-              </a:spcAft>
-              <a:defRPr sz="1300" b="0" i="0">
+                <a:spcPts val="300"/>
+              </a:spcAft>
+              <a:defRPr sz="1200" b="0" i="0">
                 <a:solidFill>
                   <a:srgbClr val="D1D5DB"/>
                 </a:solidFill>
@@ -6407,9 +6475,9 @@
                 <a:spcPct val="115000"/>
               </a:lnSpc>
               <a:spcAft>
-                <a:spcPts val="400"/>
-              </a:spcAft>
-              <a:defRPr sz="1300" b="0" i="0">
+                <a:spcPts val="300"/>
+              </a:spcAft>
+              <a:defRPr sz="1200" b="0" i="0">
                 <a:solidFill>
                   <a:srgbClr val="D1D5DB"/>
                 </a:solidFill>
@@ -6536,7 +6604,7 @@
         <p:spPr>
           <a:xfrm>
             <a:off x="731520" y="1463040"/>
-            <a:ext cx="5120640" cy="4572000"/>
+            <a:ext cx="10728655" cy="4572000"/>
           </a:xfrm>
           <a:prstGeom prst="roundRect">
             <a:avLst/>
@@ -6580,8 +6648,8 @@
         </p:nvSpPr>
         <p:spPr>
           <a:xfrm>
-            <a:off x="960120" y="1691640"/>
-            <a:ext cx="4663440" cy="4114800"/>
+            <a:off x="1097280" y="1691640"/>
+            <a:ext cx="4754880" cy="4114800"/>
           </a:xfrm>
           <a:prstGeom prst="rect">
             <a:avLst/>
@@ -6628,7 +6696,7 @@
               </a:defRPr>
             </a:pPr>
             <a:r>
-              <a:t>• Train a character-level Stacked LSTM network to generate story continuations from text prompts.</a:t>
+              <a:t>• Train a character-level recurrent neural network to generate story continuations from text prompts.</a:t>
             </a:r>
           </a:p>
           <a:p>
@@ -6647,7 +6715,7 @@
               </a:defRPr>
             </a:pPr>
             <a:r>
-              <a:t>• Forces the model to learn spelling, grammar, punctuation, and style from scratch, without using pre-defined word tokens.</a:t>
+              <a:t>• Forces the model to learn spelling, grammar, punctuation, and style from scratch, without using pre-trained word tokens.</a:t>
             </a:r>
           </a:p>
           <a:p>
@@ -6673,59 +6741,14 @@
       </p:sp>
       <p:sp>
         <p:nvSpPr>
-          <p:cNvPr id="6" name="Rounded Rectangle 5"/>
-          <p:cNvSpPr/>
-          <p:nvPr/>
-        </p:nvSpPr>
-        <p:spPr>
-          <a:xfrm>
-            <a:off x="6339535" y="1463040"/>
-            <a:ext cx="5120640" cy="4572000"/>
-          </a:xfrm>
-          <a:prstGeom prst="roundRect">
-            <a:avLst/>
-          </a:prstGeom>
-          <a:solidFill>
-            <a:srgbClr val="141B2D"/>
-          </a:solidFill>
-          <a:ln w="19050">
-            <a:solidFill>
-              <a:srgbClr val="28324B"/>
-            </a:solidFill>
-          </a:ln>
-        </p:spPr>
-        <p:style>
-          <a:lnRef idx="1">
-            <a:schemeClr val="accent1"/>
-          </a:lnRef>
-          <a:fillRef idx="3">
-            <a:schemeClr val="accent1"/>
-          </a:fillRef>
-          <a:effectRef idx="2">
-            <a:schemeClr val="accent1"/>
-          </a:effectRef>
-          <a:fontRef idx="minor">
-            <a:schemeClr val="lt1"/>
-          </a:fontRef>
-        </p:style>
-        <p:txBody>
-          <a:bodyPr rtlCol="0" anchor="ctr"/>
-          <a:lstStyle/>
-          <a:p>
-            <a:pPr algn="ctr"/>
-          </a:p>
-        </p:txBody>
-      </p:sp>
-      <p:sp>
-        <p:nvSpPr>
-          <p:cNvPr id="7" name="TextBox 6"/>
+          <p:cNvPr id="6" name="TextBox 5"/>
           <p:cNvSpPr txBox="1"/>
           <p:nvPr/>
         </p:nvSpPr>
         <p:spPr>
           <a:xfrm>
-            <a:off x="6568135" y="1691640"/>
-            <a:ext cx="4663440" cy="4114800"/>
+            <a:off x="6339535" y="1691640"/>
+            <a:ext cx="4754880" cy="4114800"/>
           </a:xfrm>
           <a:prstGeom prst="rect">
             <a:avLst/>
@@ -6929,7 +6952,7 @@
         <p:spPr>
           <a:xfrm>
             <a:off x="731520" y="1463040"/>
-            <a:ext cx="5120640" cy="4572000"/>
+            <a:ext cx="3383280" cy="4572000"/>
           </a:xfrm>
           <a:prstGeom prst="roundRect">
             <a:avLst/>
@@ -6973,8 +6996,8 @@
         </p:nvSpPr>
         <p:spPr>
           <a:xfrm>
-            <a:off x="960120" y="1691640"/>
-            <a:ext cx="4663440" cy="4114800"/>
+            <a:off x="914400" y="1645920"/>
+            <a:ext cx="3017520" cy="4206240"/>
           </a:xfrm>
           <a:prstGeom prst="rect">
             <a:avLst/>
@@ -6992,9 +7015,9 @@
                 <a:spcPct val="115000"/>
               </a:lnSpc>
               <a:spcAft>
-                <a:spcPts val="800"/>
-              </a:spcAft>
-              <a:defRPr sz="1800" b="1" i="0">
+                <a:spcPts val="1200"/>
+              </a:spcAft>
+              <a:defRPr sz="1600" b="1" i="0">
                 <a:solidFill>
                   <a:srgbClr val="FBBF24"/>
                 </a:solidFill>
@@ -7002,18 +7025,18 @@
               </a:defRPr>
             </a:pPr>
             <a:r>
-              <a:t>Why LSTM &amp; Gating Mechanism?</a:t>
-            </a:r>
-          </a:p>
-          <a:p>
-            <a:pPr>
-              <a:lnSpc>
-                <a:spcPct val="115000"/>
-              </a:lnSpc>
-              <a:spcAft>
-                <a:spcPts val="800"/>
-              </a:spcAft>
-              <a:defRPr sz="1200" b="0" i="0">
+              <a:t>Why LSTM?</a:t>
+            </a:r>
+          </a:p>
+          <a:p>
+            <a:pPr>
+              <a:lnSpc>
+                <a:spcPct val="115000"/>
+              </a:lnSpc>
+              <a:spcAft>
+                <a:spcPts val="600"/>
+              </a:spcAft>
+              <a:defRPr sz="1300" b="0" i="0">
                 <a:solidFill>
                   <a:srgbClr val="D1D5DB"/>
                 </a:solidFill>
@@ -7023,138 +7046,10 @@
             <a:r>
               <a:t>• Vanilla RNNs suffer from vanishing and exploding gradients due to repeated temporal multiplications.</a:t>
             </a:r>
-          </a:p>
-          <a:p>
-            <a:pPr>
-              <a:lnSpc>
-                <a:spcPct val="115000"/>
-              </a:lnSpc>
-              <a:spcAft>
-                <a:spcPts val="800"/>
-              </a:spcAft>
-              <a:defRPr sz="1200" b="0" i="0">
-                <a:solidFill>
-                  <a:srgbClr val="D1D5DB"/>
-                </a:solidFill>
-                <a:latin typeface="Calibri"/>
-              </a:defRPr>
-            </a:pPr>
-            <a:r>
-              <a:t>• LSTM gates control information flow through cell state (Cₜ):</a:t>
-            </a:r>
-          </a:p>
-          <a:p>
-            <a:pPr>
-              <a:lnSpc>
-                <a:spcPct val="115000"/>
-              </a:lnSpc>
-              <a:spcAft>
-                <a:spcPts val="200"/>
-              </a:spcAft>
-              <a:defRPr sz="1200" b="1" i="0">
-                <a:solidFill>
-                  <a:srgbClr val="FFFFFF"/>
-                </a:solidFill>
-                <a:latin typeface="Calibri"/>
-              </a:defRPr>
-            </a:pPr>
-            <a:r>
-              <a:t>  - Forget Gate: Decides what history to discard.</a:t>
-            </a:r>
-          </a:p>
-          <a:p>
-            <a:pPr>
-              <a:lnSpc>
-                <a:spcPct val="115000"/>
-              </a:lnSpc>
-              <a:spcAft>
-                <a:spcPts val="600"/>
-              </a:spcAft>
-              <a:defRPr sz="1300" b="1" i="0">
-                <a:solidFill>
-                  <a:srgbClr val="FBBF24"/>
-                </a:solidFill>
-                <a:latin typeface="Georgia"/>
-              </a:defRPr>
-            </a:pPr>
-            <a:r>
-              <a:t>      fₜ = σ(W_f · [hₜ₋₁, xₜ] + b_f)</a:t>
-            </a:r>
-          </a:p>
-          <a:p>
-            <a:pPr>
-              <a:lnSpc>
-                <a:spcPct val="115000"/>
-              </a:lnSpc>
-              <a:spcAft>
-                <a:spcPts val="200"/>
-              </a:spcAft>
-              <a:defRPr sz="1200" b="1" i="0">
-                <a:solidFill>
-                  <a:srgbClr val="FFFFFF"/>
-                </a:solidFill>
-                <a:latin typeface="Calibri"/>
-              </a:defRPr>
-            </a:pPr>
-            <a:r>
-              <a:t>  - Input Gate: Decides what new details to store in cell state.</a:t>
-            </a:r>
-          </a:p>
-          <a:p>
-            <a:pPr>
-              <a:lnSpc>
-                <a:spcPct val="115000"/>
-              </a:lnSpc>
-              <a:spcAft>
-                <a:spcPts val="600"/>
-              </a:spcAft>
-              <a:defRPr sz="1300" b="1" i="0">
-                <a:solidFill>
-                  <a:srgbClr val="FBBF24"/>
-                </a:solidFill>
-                <a:latin typeface="Georgia"/>
-              </a:defRPr>
-            </a:pPr>
-            <a:r>
-              <a:t>      iₜ = σ(W_i · [hₜ₋₁, xₜ] + b_i)</a:t>
-            </a:r>
-          </a:p>
-          <a:p>
-            <a:pPr>
-              <a:lnSpc>
-                <a:spcPct val="115000"/>
-              </a:lnSpc>
-              <a:spcAft>
-                <a:spcPts val="200"/>
-              </a:spcAft>
-              <a:defRPr sz="1200" b="1" i="0">
-                <a:solidFill>
-                  <a:srgbClr val="FFFFFF"/>
-                </a:solidFill>
-                <a:latin typeface="Calibri"/>
-              </a:defRPr>
-            </a:pPr>
-            <a:r>
-              <a:t>  - Output Gate: Decides what hidden state (hₜ) to output.</a:t>
-            </a:r>
-          </a:p>
-          <a:p>
-            <a:pPr>
-              <a:lnSpc>
-                <a:spcPct val="115000"/>
-              </a:lnSpc>
-              <a:spcAft>
-                <a:spcPts val="600"/>
-              </a:spcAft>
-              <a:defRPr sz="1300" b="1" i="0">
-                <a:solidFill>
-                  <a:srgbClr val="FBBF24"/>
-                </a:solidFill>
-                <a:latin typeface="Georgia"/>
-              </a:defRPr>
-            </a:pPr>
-            <a:r>
-              <a:t>      oₜ = σ(W_o · [h₁₋₁, xₜ] + b_o)</a:t>
+            <a:br/>
+            <a:br/>
+            <a:r>
+              <a:t>• LSTMs solve this by establishing cell states (Cₜ) acting as information highways where gradients can flow back freely over time.</a:t>
             </a:r>
           </a:p>
         </p:txBody>
@@ -7167,8 +7062,8 @@
         </p:nvSpPr>
         <p:spPr>
           <a:xfrm>
-            <a:off x="6339535" y="1463040"/>
-            <a:ext cx="5120640" cy="4572000"/>
+            <a:off x="4403750" y="1463040"/>
+            <a:ext cx="3383280" cy="4572000"/>
           </a:xfrm>
           <a:prstGeom prst="roundRect">
             <a:avLst/>
@@ -7212,8 +7107,8 @@
         </p:nvSpPr>
         <p:spPr>
           <a:xfrm>
-            <a:off x="6568135" y="1691640"/>
-            <a:ext cx="4663440" cy="4114800"/>
+            <a:off x="4586630" y="1645920"/>
+            <a:ext cx="3017520" cy="4206240"/>
           </a:xfrm>
           <a:prstGeom prst="rect">
             <a:avLst/>
@@ -7233,7 +7128,7 @@
               <a:spcAft>
                 <a:spcPts val="1200"/>
               </a:spcAft>
-              <a:defRPr sz="1800" b="1" i="0">
+              <a:defRPr sz="1600" b="1" i="0">
                 <a:solidFill>
                   <a:srgbClr val="FBBF24"/>
                 </a:solidFill>
@@ -7241,7 +7136,7 @@
               </a:defRPr>
             </a:pPr>
             <a:r>
-              <a:t>Our LSTM Network Configuration</a:t>
+              <a:t>Gating Mechanism</a:t>
             </a:r>
           </a:p>
           <a:p>
@@ -7252,7 +7147,7 @@
               <a:spcAft>
                 <a:spcPts val="200"/>
               </a:spcAft>
-              <a:defRPr sz="1400" b="1" i="0">
+              <a:defRPr sz="1300" b="1" i="0">
                 <a:solidFill>
                   <a:srgbClr val="FFFFFF"/>
                 </a:solidFill>
@@ -7260,106 +7155,230 @@
               </a:defRPr>
             </a:pPr>
             <a:r>
+              <a:t>• Forget Gate (f_t):</a:t>
+            </a:r>
+          </a:p>
+          <a:p>
+            <a:pPr>
+              <a:lnSpc>
+                <a:spcPct val="115000"/>
+              </a:lnSpc>
+              <a:spcAft>
+                <a:spcPts val="1000"/>
+              </a:spcAft>
+              <a:defRPr sz="1200" b="0" i="0">
+                <a:solidFill>
+                  <a:srgbClr val="D1D5DB"/>
+                </a:solidFill>
+                <a:latin typeface="Calibri"/>
+              </a:defRPr>
+            </a:pPr>
+            <a:r>
+              <a:t>  Decides what history to discard.</a:t>
+            </a:r>
+          </a:p>
+          <a:p>
+            <a:pPr>
+              <a:lnSpc>
+                <a:spcPct val="115000"/>
+              </a:lnSpc>
+              <a:spcAft>
+                <a:spcPts val="200"/>
+              </a:spcAft>
+              <a:defRPr sz="1300" b="1" i="0">
+                <a:solidFill>
+                  <a:srgbClr val="FFFFFF"/>
+                </a:solidFill>
+                <a:latin typeface="Calibri"/>
+              </a:defRPr>
+            </a:pPr>
+            <a:r>
+              <a:t>• Input Gate (i_t):</a:t>
+            </a:r>
+          </a:p>
+          <a:p>
+            <a:pPr>
+              <a:lnSpc>
+                <a:spcPct val="115000"/>
+              </a:lnSpc>
+              <a:spcAft>
+                <a:spcPts val="1000"/>
+              </a:spcAft>
+              <a:defRPr sz="1200" b="0" i="0">
+                <a:solidFill>
+                  <a:srgbClr val="D1D5DB"/>
+                </a:solidFill>
+                <a:latin typeface="Calibri"/>
+              </a:defRPr>
+            </a:pPr>
+            <a:r>
+              <a:t>  Decides what new values to write to the cell state.</a:t>
+            </a:r>
+          </a:p>
+          <a:p>
+            <a:pPr>
+              <a:lnSpc>
+                <a:spcPct val="115000"/>
+              </a:lnSpc>
+              <a:spcAft>
+                <a:spcPts val="200"/>
+              </a:spcAft>
+              <a:defRPr sz="1300" b="1" i="0">
+                <a:solidFill>
+                  <a:srgbClr val="FFFFFF"/>
+                </a:solidFill>
+                <a:latin typeface="Calibri"/>
+              </a:defRPr>
+            </a:pPr>
+            <a:r>
+              <a:t>• Output Gate (o_t):</a:t>
+            </a:r>
+          </a:p>
+          <a:p>
+            <a:pPr>
+              <a:lnSpc>
+                <a:spcPct val="115000"/>
+              </a:lnSpc>
+              <a:spcAft>
+                <a:spcPts val="600"/>
+              </a:spcAft>
+              <a:defRPr sz="1200" b="0" i="0">
+                <a:solidFill>
+                  <a:srgbClr val="D1D5DB"/>
+                </a:solidFill>
+                <a:latin typeface="Calibri"/>
+              </a:defRPr>
+            </a:pPr>
+            <a:r>
+              <a:t>  Decides what hidden state to output.</a:t>
+            </a:r>
+          </a:p>
+        </p:txBody>
+      </p:sp>
+      <p:sp>
+        <p:nvSpPr>
+          <p:cNvPr id="8" name="Rounded Rectangle 7"/>
+          <p:cNvSpPr/>
+          <p:nvPr/>
+        </p:nvSpPr>
+        <p:spPr>
+          <a:xfrm>
+            <a:off x="8076895" y="1463040"/>
+            <a:ext cx="3383280" cy="4572000"/>
+          </a:xfrm>
+          <a:prstGeom prst="roundRect">
+            <a:avLst/>
+          </a:prstGeom>
+          <a:solidFill>
+            <a:srgbClr val="141B2D"/>
+          </a:solidFill>
+          <a:ln w="19050">
+            <a:solidFill>
+              <a:srgbClr val="28324B"/>
+            </a:solidFill>
+          </a:ln>
+        </p:spPr>
+        <p:style>
+          <a:lnRef idx="1">
+            <a:schemeClr val="accent1"/>
+          </a:lnRef>
+          <a:fillRef idx="3">
+            <a:schemeClr val="accent1"/>
+          </a:fillRef>
+          <a:effectRef idx="2">
+            <a:schemeClr val="accent1"/>
+          </a:effectRef>
+          <a:fontRef idx="minor">
+            <a:schemeClr val="lt1"/>
+          </a:fontRef>
+        </p:style>
+        <p:txBody>
+          <a:bodyPr rtlCol="0" anchor="ctr"/>
+          <a:lstStyle/>
+          <a:p>
+            <a:pPr algn="ctr"/>
+          </a:p>
+        </p:txBody>
+      </p:sp>
+      <p:sp>
+        <p:nvSpPr>
+          <p:cNvPr id="9" name="TextBox 8"/>
+          <p:cNvSpPr txBox="1"/>
+          <p:nvPr/>
+        </p:nvSpPr>
+        <p:spPr>
+          <a:xfrm>
+            <a:off x="8259775" y="1645920"/>
+            <a:ext cx="3017520" cy="4206240"/>
+          </a:xfrm>
+          <a:prstGeom prst="rect">
+            <a:avLst/>
+          </a:prstGeom>
+          <a:noFill/>
+        </p:spPr>
+        <p:txBody>
+          <a:bodyPr wrap="square">
+            <a:spAutoFit/>
+          </a:bodyPr>
+          <a:lstStyle/>
+          <a:p>
+            <a:pPr>
+              <a:lnSpc>
+                <a:spcPct val="115000"/>
+              </a:lnSpc>
+              <a:spcAft>
+                <a:spcPts val="1200"/>
+              </a:spcAft>
+              <a:defRPr sz="1600" b="1" i="0">
+                <a:solidFill>
+                  <a:srgbClr val="FBBF24"/>
+                </a:solidFill>
+                <a:latin typeface="Georgia"/>
+              </a:defRPr>
+            </a:pPr>
+            <a:r>
+              <a:t>Our Network</a:t>
+            </a:r>
+          </a:p>
+          <a:p>
+            <a:pPr>
+              <a:lnSpc>
+                <a:spcPct val="115000"/>
+              </a:lnSpc>
+              <a:spcAft>
+                <a:spcPts val="600"/>
+              </a:spcAft>
+              <a:defRPr sz="1300" b="0" i="0">
+                <a:solidFill>
+                  <a:srgbClr val="D1D5DB"/>
+                </a:solidFill>
+                <a:latin typeface="Calibri"/>
+              </a:defRPr>
+            </a:pPr>
+            <a:r>
               <a:t>• Embedding Layer:</a:t>
             </a:r>
-          </a:p>
-          <a:p>
-            <a:pPr>
-              <a:lnSpc>
-                <a:spcPct val="115000"/>
-              </a:lnSpc>
-              <a:spcAft>
-                <a:spcPts val="1200"/>
-              </a:spcAft>
-              <a:defRPr sz="1300" b="0" i="0">
-                <a:solidFill>
-                  <a:srgbClr val="D1D5DB"/>
-                </a:solidFill>
-                <a:latin typeface="Calibri"/>
-              </a:defRPr>
-            </a:pPr>
-            <a:r>
-              <a:t>  - Projects character indices to 128-dimensional dense vectors.</a:t>
-            </a:r>
-          </a:p>
-          <a:p>
-            <a:pPr>
-              <a:lnSpc>
-                <a:spcPct val="115000"/>
-              </a:lnSpc>
-              <a:spcAft>
-                <a:spcPts val="200"/>
-              </a:spcAft>
-              <a:defRPr sz="1400" b="1" i="0">
-                <a:solidFill>
-                  <a:srgbClr val="FFFFFF"/>
-                </a:solidFill>
-                <a:latin typeface="Calibri"/>
-              </a:defRPr>
-            </a:pPr>
-            <a:r>
-              <a:t>• Stacked LSTM Layers:</a:t>
-            </a:r>
-          </a:p>
-          <a:p>
-            <a:pPr>
-              <a:lnSpc>
-                <a:spcPct val="115000"/>
-              </a:lnSpc>
-              <a:spcAft>
-                <a:spcPts val="1200"/>
-              </a:spcAft>
-              <a:defRPr sz="1300" b="0" i="0">
-                <a:solidFill>
-                  <a:srgbClr val="D1D5DB"/>
-                </a:solidFill>
-                <a:latin typeface="Calibri"/>
-              </a:defRPr>
-            </a:pPr>
-            <a:r>
-              <a:t>  - 2 layers with 256 hidden units each.</a:t>
-            </a:r>
             <a:br/>
             <a:r>
-              <a:t>  - Dropout rate of 0.2 after each layer to prevent overfitting.</a:t>
-            </a:r>
-          </a:p>
-          <a:p>
-            <a:pPr>
-              <a:lnSpc>
-                <a:spcPct val="115000"/>
-              </a:lnSpc>
-              <a:spcAft>
-                <a:spcPts val="200"/>
-              </a:spcAft>
-              <a:defRPr sz="1400" b="1" i="0">
-                <a:solidFill>
-                  <a:srgbClr val="FFFFFF"/>
-                </a:solidFill>
-                <a:latin typeface="Calibri"/>
-              </a:defRPr>
-            </a:pPr>
-            <a:r>
-              <a:t>• Linear Decoder Layer:</a:t>
-            </a:r>
-          </a:p>
-          <a:p>
-            <a:pPr>
-              <a:lnSpc>
-                <a:spcPct val="115000"/>
-              </a:lnSpc>
-              <a:spcAft>
-                <a:spcPts val="600"/>
-              </a:spcAft>
-              <a:defRPr sz="1300" b="0" i="0">
-                <a:solidFill>
-                  <a:srgbClr val="D1D5DB"/>
-                </a:solidFill>
-                <a:latin typeface="Calibri"/>
-              </a:defRPr>
-            </a:pPr>
-            <a:r>
-              <a:t>  - Projects the 256-dim hidden states to character vocabulary logits.</a:t>
+              <a:t>  Converts character indices to 128-dimensional dense vectors.</a:t>
+            </a:r>
+            <a:br/>
+            <a:br/>
+            <a:r>
+              <a:t>• Stacked LSTM:</a:t>
+            </a:r>
+            <a:br/>
+            <a:r>
+              <a:t>  2 layers with 256 memory units, using 0.2 Dropout to prevent overfitting.</a:t>
+            </a:r>
+            <a:br/>
+            <a:br/>
+            <a:r>
+              <a:t>• Linear Decoder:</a:t>
+            </a:r>
+            <a:br/>
+            <a:r>
+              <a:t>  Maps 256 hidden features to vocabulary logits.</a:t>
             </a:r>
           </a:p>
         </p:txBody>
@@ -7478,7 +7497,227 @@
         <p:spPr>
           <a:xfrm>
             <a:off x="731520" y="1463040"/>
-            <a:ext cx="5120640" cy="4572000"/>
+            <a:ext cx="5120640" cy="2103120"/>
+          </a:xfrm>
+          <a:prstGeom prst="roundRect">
+            <a:avLst/>
+          </a:prstGeom>
+          <a:solidFill>
+            <a:srgbClr val="141B2D"/>
+          </a:solidFill>
+          <a:ln w="19050">
+            <a:solidFill>
+              <a:srgbClr val="B47314"/>
+            </a:solidFill>
+          </a:ln>
+        </p:spPr>
+        <p:style>
+          <a:lnRef idx="1">
+            <a:schemeClr val="accent1"/>
+          </a:lnRef>
+          <a:fillRef idx="3">
+            <a:schemeClr val="accent1"/>
+          </a:fillRef>
+          <a:effectRef idx="2">
+            <a:schemeClr val="accent1"/>
+          </a:effectRef>
+          <a:fontRef idx="minor">
+            <a:schemeClr val="lt1"/>
+          </a:fontRef>
+        </p:style>
+        <p:txBody>
+          <a:bodyPr rtlCol="0" anchor="ctr"/>
+          <a:lstStyle/>
+          <a:p>
+            <a:pPr algn="ctr"/>
+          </a:p>
+        </p:txBody>
+      </p:sp>
+      <p:sp>
+        <p:nvSpPr>
+          <p:cNvPr id="5" name="TextBox 4"/>
+          <p:cNvSpPr txBox="1"/>
+          <p:nvPr/>
+        </p:nvSpPr>
+        <p:spPr>
+          <a:xfrm>
+            <a:off x="960120" y="1600200"/>
+            <a:ext cx="4663440" cy="1828800"/>
+          </a:xfrm>
+          <a:prstGeom prst="rect">
+            <a:avLst/>
+          </a:prstGeom>
+          <a:noFill/>
+        </p:spPr>
+        <p:txBody>
+          <a:bodyPr wrap="square">
+            <a:spAutoFit/>
+          </a:bodyPr>
+          <a:lstStyle/>
+          <a:p>
+            <a:pPr>
+              <a:lnSpc>
+                <a:spcPct val="115000"/>
+              </a:lnSpc>
+              <a:spcAft>
+                <a:spcPts val="400"/>
+              </a:spcAft>
+              <a:defRPr sz="1600" b="1" i="0">
+                <a:solidFill>
+                  <a:srgbClr val="FBBF24"/>
+                </a:solidFill>
+                <a:latin typeface="Georgia"/>
+              </a:defRPr>
+            </a:pPr>
+            <a:r>
+              <a:t>Shakespeare plays</a:t>
+            </a:r>
+          </a:p>
+          <a:p>
+            <a:pPr>
+              <a:lnSpc>
+                <a:spcPct val="115000"/>
+              </a:lnSpc>
+              <a:spcAft>
+                <a:spcPts val="600"/>
+              </a:spcAft>
+              <a:defRPr sz="1300" b="0" i="0">
+                <a:solidFill>
+                  <a:srgbClr val="D1D5DB"/>
+                </a:solidFill>
+                <a:latin typeface="Calibri"/>
+              </a:defRPr>
+            </a:pPr>
+            <a:r>
+              <a:t>• Dramatic old English vocabulary, poetic structures.</a:t>
+            </a:r>
+            <a:br/>
+            <a:r>
+              <a:t>• Compact vocabulary of 37 unique characters.</a:t>
+            </a:r>
+          </a:p>
+        </p:txBody>
+      </p:sp>
+      <p:sp>
+        <p:nvSpPr>
+          <p:cNvPr id="6" name="Rounded Rectangle 5"/>
+          <p:cNvSpPr/>
+          <p:nvPr/>
+        </p:nvSpPr>
+        <p:spPr>
+          <a:xfrm>
+            <a:off x="6339535" y="1463040"/>
+            <a:ext cx="5120640" cy="2103120"/>
+          </a:xfrm>
+          <a:prstGeom prst="roundRect">
+            <a:avLst/>
+          </a:prstGeom>
+          <a:solidFill>
+            <a:srgbClr val="141B2D"/>
+          </a:solidFill>
+          <a:ln w="19050">
+            <a:solidFill>
+              <a:srgbClr val="B47314"/>
+            </a:solidFill>
+          </a:ln>
+        </p:spPr>
+        <p:style>
+          <a:lnRef idx="1">
+            <a:schemeClr val="accent1"/>
+          </a:lnRef>
+          <a:fillRef idx="3">
+            <a:schemeClr val="accent1"/>
+          </a:fillRef>
+          <a:effectRef idx="2">
+            <a:schemeClr val="accent1"/>
+          </a:effectRef>
+          <a:fontRef idx="minor">
+            <a:schemeClr val="lt1"/>
+          </a:fontRef>
+        </p:style>
+        <p:txBody>
+          <a:bodyPr rtlCol="0" anchor="ctr"/>
+          <a:lstStyle/>
+          <a:p>
+            <a:pPr algn="ctr"/>
+          </a:p>
+        </p:txBody>
+      </p:sp>
+      <p:sp>
+        <p:nvSpPr>
+          <p:cNvPr id="7" name="TextBox 6"/>
+          <p:cNvSpPr txBox="1"/>
+          <p:nvPr/>
+        </p:nvSpPr>
+        <p:spPr>
+          <a:xfrm>
+            <a:off x="6568135" y="1600200"/>
+            <a:ext cx="4663440" cy="1828800"/>
+          </a:xfrm>
+          <a:prstGeom prst="rect">
+            <a:avLst/>
+          </a:prstGeom>
+          <a:noFill/>
+        </p:spPr>
+        <p:txBody>
+          <a:bodyPr wrap="square">
+            <a:spAutoFit/>
+          </a:bodyPr>
+          <a:lstStyle/>
+          <a:p>
+            <a:pPr>
+              <a:lnSpc>
+                <a:spcPct val="115000"/>
+              </a:lnSpc>
+              <a:spcAft>
+                <a:spcPts val="400"/>
+              </a:spcAft>
+              <a:defRPr sz="1600" b="1" i="0">
+                <a:solidFill>
+                  <a:srgbClr val="FBBF24"/>
+                </a:solidFill>
+                <a:latin typeface="Georgia"/>
+              </a:defRPr>
+            </a:pPr>
+            <a:r>
+              <a:t>Sherlock Holmes</a:t>
+            </a:r>
+          </a:p>
+          <a:p>
+            <a:pPr>
+              <a:lnSpc>
+                <a:spcPct val="115000"/>
+              </a:lnSpc>
+              <a:spcAft>
+                <a:spcPts val="600"/>
+              </a:spcAft>
+              <a:defRPr sz="1300" b="0" i="0">
+                <a:solidFill>
+                  <a:srgbClr val="D1D5DB"/>
+                </a:solidFill>
+                <a:latin typeface="Calibri"/>
+              </a:defRPr>
+            </a:pPr>
+            <a:r>
+              <a:t>• 19th-century detective stories, structured narrative prose.</a:t>
+            </a:r>
+            <a:br/>
+            <a:r>
+              <a:t>• Larger vocabulary of 57 unique characters.</a:t>
+            </a:r>
+          </a:p>
+        </p:txBody>
+      </p:sp>
+      <p:sp>
+        <p:nvSpPr>
+          <p:cNvPr id="8" name="Rounded Rectangle 7"/>
+          <p:cNvSpPr/>
+          <p:nvPr/>
+        </p:nvSpPr>
+        <p:spPr>
+          <a:xfrm>
+            <a:off x="731520" y="3840480"/>
+            <a:ext cx="10728655" cy="2194560"/>
           </a:xfrm>
           <a:prstGeom prst="roundRect">
             <a:avLst/>
@@ -7516,14 +7755,14 @@
       </p:sp>
       <p:sp>
         <p:nvSpPr>
-          <p:cNvPr id="5" name="TextBox 4"/>
+          <p:cNvPr id="9" name="TextBox 8"/>
           <p:cNvSpPr txBox="1"/>
           <p:nvPr/>
         </p:nvSpPr>
         <p:spPr>
           <a:xfrm>
-            <a:off x="960120" y="1691640"/>
-            <a:ext cx="4663440" cy="4114800"/>
+            <a:off x="960120" y="3977639"/>
+            <a:ext cx="4846320" cy="1920240"/>
           </a:xfrm>
           <a:prstGeom prst="rect">
             <a:avLst/>
@@ -7541,9 +7780,9 @@
                 <a:spcPct val="115000"/>
               </a:lnSpc>
               <a:spcAft>
-                <a:spcPts val="1200"/>
-              </a:spcAft>
-              <a:defRPr sz="1800" b="1" i="0">
+                <a:spcPts val="600"/>
+              </a:spcAft>
+              <a:defRPr sz="1600" b="1" i="0">
                 <a:solidFill>
                   <a:srgbClr val="FBBF24"/>
                 </a:solidFill>
@@ -7551,150 +7790,40 @@
               </a:defRPr>
             </a:pPr>
             <a:r>
-              <a:t>Contrasting Training Corpuses</a:t>
-            </a:r>
-          </a:p>
-          <a:p>
-            <a:pPr>
-              <a:lnSpc>
-                <a:spcPct val="115000"/>
-              </a:lnSpc>
-              <a:spcAft>
-                <a:spcPts val="200"/>
-              </a:spcAft>
-              <a:defRPr sz="1400" b="1" i="0">
-                <a:solidFill>
-                  <a:srgbClr val="FFFFFF"/>
+              <a:t>Preprocessing Pipeline</a:t>
+            </a:r>
+          </a:p>
+          <a:p>
+            <a:pPr>
+              <a:lnSpc>
+                <a:spcPct val="115000"/>
+              </a:lnSpc>
+              <a:spcAft>
+                <a:spcPts val="600"/>
+              </a:spcAft>
+              <a:defRPr sz="1300" b="0" i="0">
+                <a:solidFill>
+                  <a:srgbClr val="D1D5DB"/>
                 </a:solidFill>
                 <a:latin typeface="Calibri"/>
               </a:defRPr>
             </a:pPr>
             <a:r>
-              <a:t>• Shakespeare Corpus (tinyshakespeare):</a:t>
-            </a:r>
-          </a:p>
-          <a:p>
-            <a:pPr>
-              <a:lnSpc>
-                <a:spcPct val="115000"/>
-              </a:lnSpc>
-              <a:spcAft>
-                <a:spcPts val="1600"/>
-              </a:spcAft>
-              <a:defRPr sz="1300" b="0" i="0">
-                <a:solidFill>
-                  <a:srgbClr val="D1D5DB"/>
-                </a:solidFill>
-                <a:latin typeface="Calibri"/>
-              </a:defRPr>
-            </a:pPr>
-            <a:r>
-              <a:t>  - Poetic syntax, old English vocabulary, dialogue structure.</a:t>
-            </a:r>
-            <a:br/>
-            <a:r>
-              <a:t>  - Vocabulary size: 37 unique characters.</a:t>
-            </a:r>
-          </a:p>
-          <a:p>
-            <a:pPr>
-              <a:lnSpc>
-                <a:spcPct val="115000"/>
-              </a:lnSpc>
-              <a:spcAft>
-                <a:spcPts val="200"/>
-              </a:spcAft>
-              <a:defRPr sz="1400" b="1" i="0">
-                <a:solidFill>
-                  <a:srgbClr val="FFFFFF"/>
-                </a:solidFill>
-                <a:latin typeface="Calibri"/>
-              </a:defRPr>
-            </a:pPr>
-            <a:r>
-              <a:t>• Sherlock Holmes Corpus (Conan Doyle):</a:t>
-            </a:r>
-          </a:p>
-          <a:p>
-            <a:pPr>
-              <a:lnSpc>
-                <a:spcPct val="115000"/>
-              </a:lnSpc>
-              <a:spcAft>
-                <a:spcPts val="600"/>
-              </a:spcAft>
-              <a:defRPr sz="1300" b="0" i="0">
-                <a:solidFill>
-                  <a:srgbClr val="D1D5DB"/>
-                </a:solidFill>
-                <a:latin typeface="Calibri"/>
-              </a:defRPr>
-            </a:pPr>
-            <a:r>
-              <a:t>  - 19th-century detective prose, narrative syntax, descriptive style.</a:t>
-            </a:r>
-            <a:br/>
-            <a:r>
-              <a:t>  - Vocabulary size: 57 unique characters.</a:t>
-            </a:r>
-          </a:p>
-        </p:txBody>
-      </p:sp>
-      <p:sp>
-        <p:nvSpPr>
-          <p:cNvPr id="6" name="Rounded Rectangle 5"/>
-          <p:cNvSpPr/>
-          <p:nvPr/>
-        </p:nvSpPr>
-        <p:spPr>
-          <a:xfrm>
-            <a:off x="6339535" y="1463040"/>
-            <a:ext cx="5120640" cy="4572000"/>
-          </a:xfrm>
-          <a:prstGeom prst="roundRect">
-            <a:avLst/>
-          </a:prstGeom>
-          <a:solidFill>
-            <a:srgbClr val="141B2D"/>
-          </a:solidFill>
-          <a:ln w="19050">
-            <a:solidFill>
-              <a:srgbClr val="B47314"/>
-            </a:solidFill>
-          </a:ln>
-        </p:spPr>
-        <p:style>
-          <a:lnRef idx="1">
-            <a:schemeClr val="accent1"/>
-          </a:lnRef>
-          <a:fillRef idx="3">
-            <a:schemeClr val="accent1"/>
-          </a:fillRef>
-          <a:effectRef idx="2">
-            <a:schemeClr val="accent1"/>
-          </a:effectRef>
-          <a:fontRef idx="minor">
-            <a:schemeClr val="lt1"/>
-          </a:fontRef>
-        </p:style>
-        <p:txBody>
-          <a:bodyPr rtlCol="0" anchor="ctr"/>
-          <a:lstStyle/>
-          <a:p>
-            <a:pPr algn="ctr"/>
-          </a:p>
-        </p:txBody>
-      </p:sp>
-      <p:sp>
-        <p:nvSpPr>
-          <p:cNvPr id="7" name="TextBox 6"/>
+              <a:t>• Lowercase Conversion: Keeps the vocabulary size compact for faster convergence.</a:t>
+            </a:r>
+          </a:p>
+        </p:txBody>
+      </p:sp>
+      <p:sp>
+        <p:nvSpPr>
+          <p:cNvPr id="10" name="TextBox 9"/>
           <p:cNvSpPr txBox="1"/>
           <p:nvPr/>
         </p:nvSpPr>
         <p:spPr>
           <a:xfrm>
-            <a:off x="6568135" y="1691640"/>
-            <a:ext cx="4663440" cy="4114800"/>
+            <a:off x="6339535" y="3977639"/>
+            <a:ext cx="4846320" cy="1920240"/>
           </a:xfrm>
           <a:prstGeom prst="rect">
             <a:avLst/>
@@ -7712,9 +7841,9 @@
                 <a:spcPct val="115000"/>
               </a:lnSpc>
               <a:spcAft>
-                <a:spcPts val="1200"/>
-              </a:spcAft>
-              <a:defRPr sz="1800" b="1" i="0">
+                <a:spcPts val="600"/>
+              </a:spcAft>
+              <a:defRPr sz="1600" b="1" i="0">
                 <a:solidFill>
                   <a:srgbClr val="FBBF24"/>
                 </a:solidFill>
@@ -7722,91 +7851,26 @@
               </a:defRPr>
             </a:pPr>
             <a:r>
-              <a:t>Data Preprocessing &amp; Preparation</a:t>
-            </a:r>
-          </a:p>
-          <a:p>
-            <a:pPr>
-              <a:lnSpc>
-                <a:spcPct val="115000"/>
-              </a:lnSpc>
-              <a:spcAft>
-                <a:spcPts val="200"/>
-              </a:spcAft>
-              <a:defRPr sz="1400" b="1" i="0">
-                <a:solidFill>
-                  <a:srgbClr val="FFFFFF"/>
+              <a:t>Input-Target Slicing</a:t>
+            </a:r>
+          </a:p>
+          <a:p>
+            <a:pPr>
+              <a:lnSpc>
+                <a:spcPct val="115000"/>
+              </a:lnSpc>
+              <a:spcAft>
+                <a:spcPts val="600"/>
+              </a:spcAft>
+              <a:defRPr sz="1300" b="0" i="0">
+                <a:solidFill>
+                  <a:srgbClr val="D1D5DB"/>
                 </a:solidFill>
                 <a:latin typeface="Calibri"/>
               </a:defRPr>
             </a:pPr>
             <a:r>
-              <a:t>• Lowercase Normalization:</a:t>
-            </a:r>
-          </a:p>
-          <a:p>
-            <a:pPr>
-              <a:lnSpc>
-                <a:spcPct val="115000"/>
-              </a:lnSpc>
-              <a:spcAft>
-                <a:spcPts val="1600"/>
-              </a:spcAft>
-              <a:defRPr sz="1300" b="0" i="0">
-                <a:solidFill>
-                  <a:srgbClr val="D1D5DB"/>
-                </a:solidFill>
-                <a:latin typeface="Calibri"/>
-              </a:defRPr>
-            </a:pPr>
-            <a:r>
-              <a:t>  - Reduced all characters to lowercase to keep the vocabulary sizes compact, leading to faster training.</a:t>
-            </a:r>
-          </a:p>
-          <a:p>
-            <a:pPr>
-              <a:lnSpc>
-                <a:spcPct val="115000"/>
-              </a:lnSpc>
-              <a:spcAft>
-                <a:spcPts val="200"/>
-              </a:spcAft>
-              <a:defRPr sz="1400" b="1" i="0">
-                <a:solidFill>
-                  <a:srgbClr val="FFFFFF"/>
-                </a:solidFill>
-                <a:latin typeface="Calibri"/>
-              </a:defRPr>
-            </a:pPr>
-            <a:r>
-              <a:t>• Input-Target Slicing:</a:t>
-            </a:r>
-          </a:p>
-          <a:p>
-            <a:pPr>
-              <a:lnSpc>
-                <a:spcPct val="115000"/>
-              </a:lnSpc>
-              <a:spcAft>
-                <a:spcPts val="600"/>
-              </a:spcAft>
-              <a:defRPr sz="1300" b="0" i="0">
-                <a:solidFill>
-                  <a:srgbClr val="D1D5DB"/>
-                </a:solidFill>
-                <a:latin typeface="Calibri"/>
-              </a:defRPr>
-            </a:pPr>
-            <a:r>
-              <a:t>  - Sliced raw text into overlapping sequences of length T = 100.</a:t>
-            </a:r>
-            <a:br/>
-            <a:r>
-              <a:t>  - Target sequence is shifted by one character.</a:t>
-            </a:r>
-            <a:br/>
-            <a:r>
-              <a:t>  - Model learns to predict next character at each time step.</a:t>
+              <a:t>• Slices raw text into overlapping input sequences of length T = 100 characters. Target sequences are shifted by one character.</a:t>
             </a:r>
           </a:p>
         </p:txBody>
@@ -7925,7 +7989,250 @@
         <p:spPr>
           <a:xfrm>
             <a:off x="731520" y="1463040"/>
-            <a:ext cx="5120640" cy="4572000"/>
+            <a:ext cx="4114800" cy="4572000"/>
+          </a:xfrm>
+          <a:prstGeom prst="roundRect">
+            <a:avLst/>
+          </a:prstGeom>
+          <a:solidFill>
+            <a:srgbClr val="141B2D"/>
+          </a:solidFill>
+          <a:ln w="19050">
+            <a:solidFill>
+              <a:srgbClr val="28324B"/>
+            </a:solidFill>
+          </a:ln>
+        </p:spPr>
+        <p:style>
+          <a:lnRef idx="1">
+            <a:schemeClr val="accent1"/>
+          </a:lnRef>
+          <a:fillRef idx="3">
+            <a:schemeClr val="accent1"/>
+          </a:fillRef>
+          <a:effectRef idx="2">
+            <a:schemeClr val="accent1"/>
+          </a:effectRef>
+          <a:fontRef idx="minor">
+            <a:schemeClr val="lt1"/>
+          </a:fontRef>
+        </p:style>
+        <p:txBody>
+          <a:bodyPr rtlCol="0" anchor="ctr"/>
+          <a:lstStyle/>
+          <a:p>
+            <a:pPr algn="ctr"/>
+          </a:p>
+        </p:txBody>
+      </p:sp>
+      <p:sp>
+        <p:nvSpPr>
+          <p:cNvPr id="5" name="TextBox 4"/>
+          <p:cNvSpPr txBox="1"/>
+          <p:nvPr/>
+        </p:nvSpPr>
+        <p:spPr>
+          <a:xfrm>
+            <a:off x="960120" y="1691640"/>
+            <a:ext cx="3657600" cy="4114800"/>
+          </a:xfrm>
+          <a:prstGeom prst="rect">
+            <a:avLst/>
+          </a:prstGeom>
+          <a:noFill/>
+        </p:spPr>
+        <p:txBody>
+          <a:bodyPr wrap="square">
+            <a:spAutoFit/>
+          </a:bodyPr>
+          <a:lstStyle/>
+          <a:p>
+            <a:pPr>
+              <a:lnSpc>
+                <a:spcPct val="115000"/>
+              </a:lnSpc>
+              <a:spcAft>
+                <a:spcPts val="1200"/>
+              </a:spcAft>
+              <a:defRPr sz="1800" b="1" i="0">
+                <a:solidFill>
+                  <a:srgbClr val="FBBF24"/>
+                </a:solidFill>
+                <a:latin typeface="Georgia"/>
+              </a:defRPr>
+            </a:pPr>
+            <a:r>
+              <a:t>Decoding Overview</a:t>
+            </a:r>
+          </a:p>
+          <a:p>
+            <a:pPr>
+              <a:lnSpc>
+                <a:spcPct val="115000"/>
+              </a:lnSpc>
+              <a:spcAft>
+                <a:spcPts val="1200"/>
+              </a:spcAft>
+              <a:defRPr sz="1300" b="0" i="0">
+                <a:solidFill>
+                  <a:srgbClr val="D1D5DB"/>
+                </a:solidFill>
+                <a:latin typeface="Calibri"/>
+              </a:defRPr>
+            </a:pPr>
+            <a:r>
+              <a:t>• Greedy Decoding (T = 0):</a:t>
+            </a:r>
+            <a:br/>
+            <a:r>
+              <a:t>  - Always selects the character with the absolute highest probability.</a:t>
+            </a:r>
+            <a:br/>
+            <a:r>
+              <a:t>  - Very deterministic, but highly prone to getting stuck in infinite repeating loops.</a:t>
+            </a:r>
+          </a:p>
+          <a:p>
+            <a:pPr>
+              <a:lnSpc>
+                <a:spcPct val="115000"/>
+              </a:lnSpc>
+              <a:spcAft>
+                <a:spcPts val="600"/>
+              </a:spcAft>
+              <a:defRPr sz="1300" b="0" i="0">
+                <a:solidFill>
+                  <a:srgbClr val="D1D5DB"/>
+                </a:solidFill>
+                <a:latin typeface="Calibri"/>
+              </a:defRPr>
+            </a:pPr>
+            <a:r>
+              <a:t>• Temperature Sampling (T &gt; 0):</a:t>
+            </a:r>
+            <a:br/>
+            <a:r>
+              <a:t>  - Scales the logits by dividing them by T before applying Softmax to control randomness.</a:t>
+            </a:r>
+          </a:p>
+        </p:txBody>
+      </p:sp>
+      <p:sp>
+        <p:nvSpPr>
+          <p:cNvPr id="6" name="Rounded Rectangle 5"/>
+          <p:cNvSpPr/>
+          <p:nvPr/>
+        </p:nvSpPr>
+        <p:spPr>
+          <a:xfrm>
+            <a:off x="5120640" y="1463040"/>
+            <a:ext cx="6339535" cy="1280160"/>
+          </a:xfrm>
+          <a:prstGeom prst="roundRect">
+            <a:avLst/>
+          </a:prstGeom>
+          <a:solidFill>
+            <a:srgbClr val="141B2D"/>
+          </a:solidFill>
+          <a:ln w="19050">
+            <a:solidFill>
+              <a:srgbClr val="28324B"/>
+            </a:solidFill>
+          </a:ln>
+        </p:spPr>
+        <p:style>
+          <a:lnRef idx="1">
+            <a:schemeClr val="accent1"/>
+          </a:lnRef>
+          <a:fillRef idx="3">
+            <a:schemeClr val="accent1"/>
+          </a:fillRef>
+          <a:effectRef idx="2">
+            <a:schemeClr val="accent1"/>
+          </a:effectRef>
+          <a:fontRef idx="minor">
+            <a:schemeClr val="lt1"/>
+          </a:fontRef>
+        </p:style>
+        <p:txBody>
+          <a:bodyPr rtlCol="0" anchor="ctr"/>
+          <a:lstStyle/>
+          <a:p>
+            <a:pPr algn="ctr"/>
+          </a:p>
+        </p:txBody>
+      </p:sp>
+      <p:sp>
+        <p:nvSpPr>
+          <p:cNvPr id="7" name="TextBox 6"/>
+          <p:cNvSpPr txBox="1"/>
+          <p:nvPr/>
+        </p:nvSpPr>
+        <p:spPr>
+          <a:xfrm>
+            <a:off x="5349240" y="1600200"/>
+            <a:ext cx="5882335" cy="1005840"/>
+          </a:xfrm>
+          <a:prstGeom prst="rect">
+            <a:avLst/>
+          </a:prstGeom>
+          <a:noFill/>
+        </p:spPr>
+        <p:txBody>
+          <a:bodyPr wrap="square">
+            <a:spAutoFit/>
+          </a:bodyPr>
+          <a:lstStyle/>
+          <a:p>
+            <a:pPr>
+              <a:lnSpc>
+                <a:spcPct val="115000"/>
+              </a:lnSpc>
+              <a:spcAft>
+                <a:spcPts val="200"/>
+              </a:spcAft>
+              <a:defRPr sz="1400" b="1" i="0">
+                <a:solidFill>
+                  <a:srgbClr val="FFFFFF"/>
+                </a:solidFill>
+                <a:latin typeface="Georgia"/>
+              </a:defRPr>
+            </a:pPr>
+            <a:r>
+              <a:t>Low Temperature (T = 0.2)</a:t>
+            </a:r>
+          </a:p>
+          <a:p>
+            <a:pPr>
+              <a:lnSpc>
+                <a:spcPct val="115000"/>
+              </a:lnSpc>
+              <a:spcAft>
+                <a:spcPts val="600"/>
+              </a:spcAft>
+              <a:defRPr sz="1200" b="0" i="0">
+                <a:solidFill>
+                  <a:srgbClr val="D1D5DB"/>
+                </a:solidFill>
+                <a:latin typeface="Calibri"/>
+              </a:defRPr>
+            </a:pPr>
+            <a:r>
+              <a:t>• Highly conservative, repetitive, and safe output. Vocabulary remains narrow.</a:t>
+            </a:r>
+          </a:p>
+        </p:txBody>
+      </p:sp>
+      <p:sp>
+        <p:nvSpPr>
+          <p:cNvPr id="8" name="Rounded Rectangle 7"/>
+          <p:cNvSpPr/>
+          <p:nvPr/>
+        </p:nvSpPr>
+        <p:spPr>
+          <a:xfrm>
+            <a:off x="5120640" y="3108960"/>
+            <a:ext cx="6339535" cy="1280160"/>
           </a:xfrm>
           <a:prstGeom prst="roundRect">
             <a:avLst/>
@@ -7963,14 +8270,14 @@
       </p:sp>
       <p:sp>
         <p:nvSpPr>
-          <p:cNvPr id="5" name="TextBox 4"/>
+          <p:cNvPr id="9" name="TextBox 8"/>
           <p:cNvSpPr txBox="1"/>
           <p:nvPr/>
         </p:nvSpPr>
         <p:spPr>
           <a:xfrm>
-            <a:off x="960120" y="1691640"/>
-            <a:ext cx="4663440" cy="4114800"/>
+            <a:off x="5349240" y="3246120"/>
+            <a:ext cx="5882335" cy="1005840"/>
           </a:xfrm>
           <a:prstGeom prst="rect">
             <a:avLst/>
@@ -7988,9 +8295,9 @@
                 <a:spcPct val="115000"/>
               </a:lnSpc>
               <a:spcAft>
-                <a:spcPts val="1200"/>
-              </a:spcAft>
-              <a:defRPr sz="1800" b="1" i="0">
+                <a:spcPts val="200"/>
+              </a:spcAft>
+              <a:defRPr sz="1400" b="1" i="0">
                 <a:solidFill>
                   <a:srgbClr val="FBBF24"/>
                 </a:solidFill>
@@ -7998,120 +8305,40 @@
               </a:defRPr>
             </a:pPr>
             <a:r>
-              <a:t>Greedy vs. Temperature Sampling</a:t>
-            </a:r>
-          </a:p>
-          <a:p>
-            <a:pPr>
-              <a:lnSpc>
-                <a:spcPct val="115000"/>
-              </a:lnSpc>
-              <a:spcAft>
-                <a:spcPts val="200"/>
-              </a:spcAft>
-              <a:defRPr sz="1400" b="1" i="0">
-                <a:solidFill>
-                  <a:srgbClr val="FFFFFF"/>
+              <a:t>Balanced Temperature (T = 0.6) — Recommended</a:t>
+            </a:r>
+          </a:p>
+          <a:p>
+            <a:pPr>
+              <a:lnSpc>
+                <a:spcPct val="115000"/>
+              </a:lnSpc>
+              <a:spcAft>
+                <a:spcPts val="600"/>
+              </a:spcAft>
+              <a:defRPr sz="1200" b="0" i="0">
+                <a:solidFill>
+                  <a:srgbClr val="D1D5DB"/>
                 </a:solidFill>
                 <a:latin typeface="Calibri"/>
               </a:defRPr>
             </a:pPr>
             <a:r>
-              <a:t>• Greedy Decoding (T = 0):</a:t>
-            </a:r>
-          </a:p>
-          <a:p>
-            <a:pPr>
-              <a:lnSpc>
-                <a:spcPct val="115000"/>
-              </a:lnSpc>
-              <a:spcAft>
-                <a:spcPts val="1200"/>
-              </a:spcAft>
-              <a:defRPr sz="1300" b="0" i="0">
-                <a:solidFill>
-                  <a:srgbClr val="D1D5DB"/>
-                </a:solidFill>
-                <a:latin typeface="Calibri"/>
-              </a:defRPr>
-            </a:pPr>
-            <a:r>
-              <a:t>  - Always selects the character with the maximum probability.</a:t>
-            </a:r>
-            <a:br/>
-            <a:r>
-              <a:t>  - Highly deterministic, but prone to repeating words and getting stuck in infinite loops.</a:t>
-            </a:r>
-          </a:p>
-          <a:p>
-            <a:pPr>
-              <a:lnSpc>
-                <a:spcPct val="115000"/>
-              </a:lnSpc>
-              <a:spcAft>
-                <a:spcPts val="200"/>
-              </a:spcAft>
-              <a:defRPr sz="1400" b="1" i="0">
-                <a:solidFill>
-                  <a:srgbClr val="FFFFFF"/>
-                </a:solidFill>
-                <a:latin typeface="Calibri"/>
-              </a:defRPr>
-            </a:pPr>
-            <a:r>
-              <a:t>• Temperature Sampling (T &gt; 0):</a:t>
-            </a:r>
-          </a:p>
-          <a:p>
-            <a:pPr>
-              <a:lnSpc>
-                <a:spcPct val="115000"/>
-              </a:lnSpc>
-              <a:spcAft>
-                <a:spcPts val="400"/>
-              </a:spcAft>
-              <a:defRPr sz="1300" b="0" i="0">
-                <a:solidFill>
-                  <a:srgbClr val="D1D5DB"/>
-                </a:solidFill>
-                <a:latin typeface="Calibri"/>
-              </a:defRPr>
-            </a:pPr>
-            <a:r>
-              <a:t>  - Scales logits before the Softmax function to adjust entropy:</a:t>
-            </a:r>
-          </a:p>
-          <a:p>
-            <a:pPr>
-              <a:lnSpc>
-                <a:spcPct val="115000"/>
-              </a:lnSpc>
-              <a:spcAft>
-                <a:spcPts val="600"/>
-              </a:spcAft>
-              <a:defRPr sz="1600" b="1" i="0">
-                <a:solidFill>
-                  <a:srgbClr val="FBBF24"/>
-                </a:solidFill>
-                <a:latin typeface="Georgia"/>
-              </a:defRPr>
-            </a:pPr>
-            <a:r>
-              <a:t>      P(cᵢ) = exp(logits_i / T) / Σⱼ exp(logits_j / T)</a:t>
-            </a:r>
-          </a:p>
-        </p:txBody>
-      </p:sp>
-      <p:sp>
-        <p:nvSpPr>
-          <p:cNvPr id="6" name="Rounded Rectangle 5"/>
+              <a:t>• High quality output: creative and styled language with correct spelling.</a:t>
+            </a:r>
+          </a:p>
+        </p:txBody>
+      </p:sp>
+      <p:sp>
+        <p:nvSpPr>
+          <p:cNvPr id="10" name="Rounded Rectangle 9"/>
           <p:cNvSpPr/>
           <p:nvPr/>
         </p:nvSpPr>
         <p:spPr>
           <a:xfrm>
-            <a:off x="6339535" y="1463040"/>
-            <a:ext cx="5120640" cy="4572000"/>
+            <a:off x="5120640" y="4754880"/>
+            <a:ext cx="6339535" cy="1280160"/>
           </a:xfrm>
           <a:prstGeom prst="roundRect">
             <a:avLst/>
@@ -8149,14 +8376,14 @@
       </p:sp>
       <p:sp>
         <p:nvSpPr>
-          <p:cNvPr id="7" name="TextBox 6"/>
+          <p:cNvPr id="11" name="TextBox 10"/>
           <p:cNvSpPr txBox="1"/>
           <p:nvPr/>
         </p:nvSpPr>
         <p:spPr>
           <a:xfrm>
-            <a:off x="6568135" y="1691640"/>
-            <a:ext cx="4663440" cy="4114800"/>
+            <a:off x="5349240" y="4892040"/>
+            <a:ext cx="5882335" cy="1005840"/>
           </a:xfrm>
           <a:prstGeom prst="rect">
             <a:avLst/>
@@ -8174,131 +8401,36 @@
                 <a:spcPct val="115000"/>
               </a:lnSpc>
               <a:spcAft>
-                <a:spcPts val="1200"/>
-              </a:spcAft>
-              <a:defRPr sz="1800" b="1" i="0">
-                <a:solidFill>
-                  <a:srgbClr val="FBBF24"/>
+                <a:spcPts val="200"/>
+              </a:spcAft>
+              <a:defRPr sz="1400" b="1" i="0">
+                <a:solidFill>
+                  <a:srgbClr val="FFFFFF"/>
                 </a:solidFill>
                 <a:latin typeface="Georgia"/>
               </a:defRPr>
             </a:pPr>
             <a:r>
-              <a:t>Effects of Temperature Settings</a:t>
-            </a:r>
-          </a:p>
-          <a:p>
-            <a:pPr>
-              <a:lnSpc>
-                <a:spcPct val="115000"/>
-              </a:lnSpc>
-              <a:spcAft>
-                <a:spcPts val="200"/>
-              </a:spcAft>
-              <a:defRPr sz="1400" b="1" i="0">
-                <a:solidFill>
-                  <a:srgbClr val="FFFFFF"/>
+              <a:t>High Temperature (T = 1.5)</a:t>
+            </a:r>
+          </a:p>
+          <a:p>
+            <a:pPr>
+              <a:lnSpc>
+                <a:spcPct val="115000"/>
+              </a:lnSpc>
+              <a:spcAft>
+                <a:spcPts val="600"/>
+              </a:spcAft>
+              <a:defRPr sz="1200" b="0" i="0">
+                <a:solidFill>
+                  <a:srgbClr val="D1D5DB"/>
                 </a:solidFill>
                 <a:latin typeface="Calibri"/>
               </a:defRPr>
             </a:pPr>
             <a:r>
-              <a:t>• Low Temperature (T = 0.2):</a:t>
-            </a:r>
-          </a:p>
-          <a:p>
-            <a:pPr>
-              <a:lnSpc>
-                <a:spcPct val="115000"/>
-              </a:lnSpc>
-              <a:spcAft>
-                <a:spcPts val="1600"/>
-              </a:spcAft>
-              <a:defRPr sz="1300" b="0" i="0">
-                <a:solidFill>
-                  <a:srgbClr val="D1D5DB"/>
-                </a:solidFill>
-                <a:latin typeface="Calibri"/>
-              </a:defRPr>
-            </a:pPr>
-            <a:r>
-              <a:t>  - Very conservative output, highly repetitive, lacks creativity.</a:t>
-            </a:r>
-          </a:p>
-          <a:p>
-            <a:pPr>
-              <a:lnSpc>
-                <a:spcPct val="115000"/>
-              </a:lnSpc>
-              <a:spcAft>
-                <a:spcPts val="200"/>
-              </a:spcAft>
-              <a:defRPr sz="1400" b="1" i="0">
-                <a:solidFill>
-                  <a:srgbClr val="FFFFFF"/>
-                </a:solidFill>
-                <a:latin typeface="Calibri"/>
-              </a:defRPr>
-            </a:pPr>
-            <a:r>
-              <a:t>• Moderate Temperature (T = 0.6):</a:t>
-            </a:r>
-          </a:p>
-          <a:p>
-            <a:pPr>
-              <a:lnSpc>
-                <a:spcPct val="115000"/>
-              </a:lnSpc>
-              <a:spcAft>
-                <a:spcPts val="1600"/>
-              </a:spcAft>
-              <a:defRPr sz="1300" b="0" i="0">
-                <a:solidFill>
-                  <a:srgbClr val="D1D5DB"/>
-                </a:solidFill>
-                <a:latin typeface="Calibri"/>
-              </a:defRPr>
-            </a:pPr>
-            <a:r>
-              <a:t>  - Optimal balance: creative vocabulary, fluent syntax, and very few spelling/grammar mistakes.</a:t>
-            </a:r>
-          </a:p>
-          <a:p>
-            <a:pPr>
-              <a:lnSpc>
-                <a:spcPct val="115000"/>
-              </a:lnSpc>
-              <a:spcAft>
-                <a:spcPts val="200"/>
-              </a:spcAft>
-              <a:defRPr sz="1400" b="1" i="0">
-                <a:solidFill>
-                  <a:srgbClr val="FFFFFF"/>
-                </a:solidFill>
-                <a:latin typeface="Calibri"/>
-              </a:defRPr>
-            </a:pPr>
-            <a:r>
-              <a:t>• High Temperature (T &gt;= 1.0):</a:t>
-            </a:r>
-          </a:p>
-          <a:p>
-            <a:pPr>
-              <a:lnSpc>
-                <a:spcPct val="115000"/>
-              </a:lnSpc>
-              <a:spcAft>
-                <a:spcPts val="600"/>
-              </a:spcAft>
-              <a:defRPr sz="1300" b="0" i="0">
-                <a:solidFill>
-                  <a:srgbClr val="D1D5DB"/>
-                </a:solidFill>
-                <a:latin typeface="Calibri"/>
-              </a:defRPr>
-            </a:pPr>
-            <a:r>
-              <a:t>  - Extreme entropy: highly chaotic, frequent spelling mistakes, outputs look like random gibberish.</a:t>
+              <a:t>• Complete chaos. Grammatical structure collapses and words disintegrate into random gibberish.</a:t>
             </a:r>
           </a:p>
         </p:txBody>
@@ -8551,7 +8683,7 @@
               </a:defRPr>
             </a:pPr>
             <a:r>
-              <a:t>• Stylistic Comparison (Prompt: "the secret of ")</a:t>
+              <a:t>• Generated Samples (Prompt: "the secret of ")</a:t>
             </a:r>
           </a:p>
           <a:p>
@@ -8815,7 +8947,7 @@
         <p:spPr>
           <a:xfrm>
             <a:off x="731520" y="1463040"/>
-            <a:ext cx="5120640" cy="4572000"/>
+            <a:ext cx="10728655" cy="4572000"/>
           </a:xfrm>
           <a:prstGeom prst="roundRect">
             <a:avLst/>
@@ -8859,8 +8991,8 @@
         </p:nvSpPr>
         <p:spPr>
           <a:xfrm>
-            <a:off x="960120" y="1691640"/>
-            <a:ext cx="4663440" cy="4114800"/>
+            <a:off x="1097280" y="1691640"/>
+            <a:ext cx="4754880" cy="4114800"/>
           </a:xfrm>
           <a:prstGeom prst="rect">
             <a:avLst/>
@@ -8916,7 +9048,7 @@
                 <a:spcPct val="115000"/>
               </a:lnSpc>
               <a:spcAft>
-                <a:spcPts val="1200"/>
+                <a:spcPts val="600"/>
               </a:spcAft>
               <a:defRPr sz="1400" b="0" i="0">
                 <a:solidFill>
@@ -8929,82 +9061,18 @@
               <a:t>• Systematically evaluate convergence speed, final test accuracy, and stability under different optimization stress-tests.</a:t>
             </a:r>
           </a:p>
-          <a:p>
-            <a:pPr>
-              <a:lnSpc>
-                <a:spcPct val="115000"/>
-              </a:lnSpc>
-              <a:spcAft>
-                <a:spcPts val="600"/>
-              </a:spcAft>
-              <a:defRPr sz="1400" b="0" i="0">
-                <a:solidFill>
-                  <a:srgbClr val="D1D5DB"/>
-                </a:solidFill>
-                <a:latin typeface="Calibri"/>
-              </a:defRPr>
-            </a:pPr>
-            <a:r>
-              <a:t>• Provide empirical evidence demonstrating how normalization rescues deep models from training failure.</a:t>
-            </a:r>
-          </a:p>
-        </p:txBody>
-      </p:sp>
-      <p:sp>
-        <p:nvSpPr>
-          <p:cNvPr id="6" name="Rounded Rectangle 5"/>
-          <p:cNvSpPr/>
-          <p:nvPr/>
-        </p:nvSpPr>
-        <p:spPr>
-          <a:xfrm>
-            <a:off x="6339535" y="1463040"/>
-            <a:ext cx="5120640" cy="4572000"/>
-          </a:xfrm>
-          <a:prstGeom prst="roundRect">
-            <a:avLst/>
-          </a:prstGeom>
-          <a:solidFill>
-            <a:srgbClr val="141B2D"/>
-          </a:solidFill>
-          <a:ln w="19050">
-            <a:solidFill>
-              <a:srgbClr val="28324B"/>
-            </a:solidFill>
-          </a:ln>
-        </p:spPr>
-        <p:style>
-          <a:lnRef idx="1">
-            <a:schemeClr val="accent1"/>
-          </a:lnRef>
-          <a:fillRef idx="3">
-            <a:schemeClr val="accent1"/>
-          </a:fillRef>
-          <a:effectRef idx="2">
-            <a:schemeClr val="accent1"/>
-          </a:effectRef>
-          <a:fontRef idx="minor">
-            <a:schemeClr val="lt1"/>
-          </a:fontRef>
-        </p:style>
-        <p:txBody>
-          <a:bodyPr rtlCol="0" anchor="ctr"/>
-          <a:lstStyle/>
-          <a:p>
-            <a:pPr algn="ctr"/>
-          </a:p>
-        </p:txBody>
-      </p:sp>
-      <p:sp>
-        <p:nvSpPr>
-          <p:cNvPr id="7" name="TextBox 6"/>
+        </p:txBody>
+      </p:sp>
+      <p:sp>
+        <p:nvSpPr>
+          <p:cNvPr id="6" name="TextBox 5"/>
           <p:cNvSpPr txBox="1"/>
           <p:nvPr/>
         </p:nvSpPr>
         <p:spPr>
           <a:xfrm>
-            <a:off x="6568135" y="1691640"/>
-            <a:ext cx="4663440" cy="4114800"/>
+            <a:off x="6339535" y="1691640"/>
+            <a:ext cx="4754880" cy="4114800"/>
           </a:xfrm>
           <a:prstGeom prst="rect">
             <a:avLst/>
@@ -9032,7 +9100,7 @@
               </a:defRPr>
             </a:pPr>
             <a:r>
-              <a:t>Key Challenges in Deep Networks</a:t>
+              <a:t>Core Challenges in Deep Networks</a:t>
             </a:r>
           </a:p>
           <a:p>
@@ -9060,7 +9128,7 @@
                 <a:spcPct val="115000"/>
               </a:lnSpc>
               <a:spcAft>
-                <a:spcPts val="1600"/>
+                <a:spcPts val="1200"/>
               </a:spcAft>
               <a:defRPr sz="1300" b="0" i="0">
                 <a:solidFill>
@@ -9070,7 +9138,7 @@
               </a:defRPr>
             </a:pPr>
             <a:r>
-              <a:t>  - Distributions of layer activations shift continuously as weights update during training, forcing later layers to constantly adapt.</a:t>
+              <a:t>  - Activation distributions shift continuously as weights update during training, slowing down training and forcing small learning rates.</a:t>
             </a:r>
           </a:p>
           <a:p>
@@ -9089,7 +9157,7 @@
               </a:defRPr>
             </a:pPr>
             <a:r>
-              <a:t>• Vanishing &amp; Exploding Gradients:</a:t>
+              <a:t>• Vanishing/Exploding Gradients:</a:t>
             </a:r>
           </a:p>
           <a:p>
@@ -9108,7 +9176,7 @@
               </a:defRPr>
             </a:pPr>
             <a:r>
-              <a:t>  - Error signals shrink to near-zero or expand exponentially as they propagate backward through many layers, halting learning.</a:t>
+              <a:t>  - Signals vanish or blow up as they propagate through deep layers, stopping learning or causing divergence.</a:t>
             </a:r>
           </a:p>
         </p:txBody>
@@ -9227,7 +9295,7 @@
         <p:spPr>
           <a:xfrm>
             <a:off x="731520" y="1463040"/>
-            <a:ext cx="5120640" cy="4572000"/>
+            <a:ext cx="3383280" cy="4572000"/>
           </a:xfrm>
           <a:prstGeom prst="roundRect">
             <a:avLst/>
@@ -9271,8 +9339,8 @@
         </p:nvSpPr>
         <p:spPr>
           <a:xfrm>
-            <a:off x="960120" y="1691640"/>
-            <a:ext cx="4663440" cy="4114800"/>
+            <a:off x="914400" y="1645920"/>
+            <a:ext cx="3017520" cy="4206240"/>
           </a:xfrm>
           <a:prstGeom prst="rect">
             <a:avLst/>
@@ -9292,7 +9360,7 @@
               <a:spcAft>
                 <a:spcPts val="1200"/>
               </a:spcAft>
-              <a:defRPr sz="1800" b="1" i="0">
+              <a:defRPr sz="1600" b="1" i="0">
                 <a:solidFill>
                   <a:srgbClr val="FBBF24"/>
                 </a:solidFill>
@@ -9300,140 +9368,39 @@
               </a:defRPr>
             </a:pPr>
             <a:r>
-              <a:t>Dataset &amp; Model Configuration</a:t>
-            </a:r>
-          </a:p>
-          <a:p>
-            <a:pPr>
-              <a:lnSpc>
-                <a:spcPct val="115000"/>
-              </a:lnSpc>
-              <a:spcAft>
-                <a:spcPts val="200"/>
-              </a:spcAft>
-              <a:defRPr sz="1400" b="1" i="0">
-                <a:solidFill>
-                  <a:srgbClr val="FFFFFF"/>
+              <a:t>Dataset</a:t>
+            </a:r>
+          </a:p>
+          <a:p>
+            <a:pPr>
+              <a:lnSpc>
+                <a:spcPct val="115000"/>
+              </a:lnSpc>
+              <a:spcAft>
+                <a:spcPts val="600"/>
+              </a:spcAft>
+              <a:defRPr sz="1300" b="0" i="0">
+                <a:solidFill>
+                  <a:srgbClr val="D1D5DB"/>
                 </a:solidFill>
                 <a:latin typeface="Calibri"/>
               </a:defRPr>
             </a:pPr>
             <a:r>
-              <a:t>• Dataset: MNIST Handwritten Digits</a:t>
-            </a:r>
-          </a:p>
-          <a:p>
-            <a:pPr>
-              <a:lnSpc>
-                <a:spcPct val="115000"/>
-              </a:lnSpc>
-              <a:spcAft>
-                <a:spcPts val="1200"/>
-              </a:spcAft>
-              <a:defRPr sz="1300" b="0" i="0">
-                <a:solidFill>
-                  <a:srgbClr val="D1D5DB"/>
-                </a:solidFill>
-                <a:latin typeface="Calibri"/>
-              </a:defRPr>
-            </a:pPr>
-            <a:r>
-              <a:t>  - 60,000 training images, 10,000 test images (28x28 grayscale digits).</a:t>
-            </a:r>
-          </a:p>
-          <a:p>
-            <a:pPr>
-              <a:lnSpc>
-                <a:spcPct val="115000"/>
-              </a:lnSpc>
-              <a:spcAft>
-                <a:spcPts val="200"/>
-              </a:spcAft>
-              <a:defRPr sz="1400" b="1" i="0">
-                <a:solidFill>
-                  <a:srgbClr val="FFFFFF"/>
-                </a:solidFill>
-                <a:latin typeface="Calibri"/>
-              </a:defRPr>
-            </a:pPr>
-            <a:r>
-              <a:t>• Network Dimensions:</a:t>
-            </a:r>
-          </a:p>
-          <a:p>
-            <a:pPr>
-              <a:lnSpc>
-                <a:spcPct val="115000"/>
-              </a:lnSpc>
-              <a:spcAft>
-                <a:spcPts val="400"/>
-              </a:spcAft>
-              <a:defRPr sz="1300" b="0" i="0">
-                <a:solidFill>
-                  <a:srgbClr val="D1D5DB"/>
-                </a:solidFill>
-                <a:latin typeface="Calibri"/>
-              </a:defRPr>
-            </a:pPr>
-            <a:r>
-              <a:t>  - Input Layer: Flattened image vector of size 784.</a:t>
-            </a:r>
-          </a:p>
-          <a:p>
-            <a:pPr>
-              <a:lnSpc>
-                <a:spcPct val="115000"/>
-              </a:lnSpc>
-              <a:spcAft>
-                <a:spcPts val="400"/>
-              </a:spcAft>
-              <a:defRPr sz="1300" b="0" i="0">
-                <a:solidFill>
-                  <a:srgbClr val="D1D5DB"/>
-                </a:solidFill>
-                <a:latin typeface="Calibri"/>
-              </a:defRPr>
-            </a:pPr>
-            <a:r>
-              <a:t>  - Hidden Layers: 5 layers with 512 hidden units each.</a:t>
-            </a:r>
-          </a:p>
-          <a:p>
-            <a:pPr>
-              <a:lnSpc>
-                <a:spcPct val="115000"/>
-              </a:lnSpc>
-              <a:spcAft>
-                <a:spcPts val="400"/>
-              </a:spcAft>
-              <a:defRPr sz="1300" b="0" i="0">
-                <a:solidFill>
-                  <a:srgbClr val="D1D5DB"/>
-                </a:solidFill>
-                <a:latin typeface="Calibri"/>
-              </a:defRPr>
-            </a:pPr>
-            <a:r>
-              <a:t>  - Output Layer: 10 units with Softmax for digit class logits.</a:t>
-            </a:r>
-          </a:p>
-          <a:p>
-            <a:pPr>
-              <a:lnSpc>
-                <a:spcPct val="115000"/>
-              </a:lnSpc>
-              <a:spcAft>
-                <a:spcPts val="600"/>
-              </a:spcAft>
-              <a:defRPr sz="1300" b="0" i="0">
-                <a:solidFill>
-                  <a:srgbClr val="D1D5DB"/>
-                </a:solidFill>
-                <a:latin typeface="Calibri"/>
-              </a:defRPr>
-            </a:pPr>
-            <a:r>
-              <a:t>  - Activation Function: Rectified Linear Unit (ReLU) after each layer.</a:t>
+              <a:t>• MNIST Digits Classification:</a:t>
+            </a:r>
+            <a:br/>
+            <a:r>
+              <a:t>  Grayscale 28x28 handwritten digit images.</a:t>
+            </a:r>
+            <a:br/>
+            <a:br/>
+            <a:r>
+              <a:t>• Splits:</a:t>
+            </a:r>
+            <a:br/>
+            <a:r>
+              <a:t>  60,000 training samples and 10,000 testing samples, divided into 10 class categories.</a:t>
             </a:r>
           </a:p>
         </p:txBody>
@@ -9446,8 +9413,8 @@
         </p:nvSpPr>
         <p:spPr>
           <a:xfrm>
-            <a:off x="6339535" y="1463040"/>
-            <a:ext cx="5120640" cy="4572000"/>
+            <a:off x="4403750" y="1463040"/>
+            <a:ext cx="3383280" cy="4572000"/>
           </a:xfrm>
           <a:prstGeom prst="roundRect">
             <a:avLst/>
@@ -9491,8 +9458,8 @@
         </p:nvSpPr>
         <p:spPr>
           <a:xfrm>
-            <a:off x="6568135" y="1691640"/>
-            <a:ext cx="4663440" cy="4114800"/>
+            <a:off x="4586630" y="1645920"/>
+            <a:ext cx="3017520" cy="4206240"/>
           </a:xfrm>
           <a:prstGeom prst="rect">
             <a:avLst/>
@@ -9512,7 +9479,7 @@
               <a:spcAft>
                 <a:spcPts val="1200"/>
               </a:spcAft>
-              <a:defRPr sz="1800" b="1" i="0">
+              <a:defRPr sz="1600" b="1" i="0">
                 <a:solidFill>
                   <a:srgbClr val="FBBF24"/>
                 </a:solidFill>
@@ -9520,35 +9487,153 @@
               </a:defRPr>
             </a:pPr>
             <a:r>
-              <a:t>Comparative Experimental Setups</a:t>
-            </a:r>
-          </a:p>
-          <a:p>
-            <a:pPr>
-              <a:lnSpc>
-                <a:spcPct val="115000"/>
-              </a:lnSpc>
-              <a:spcAft>
-                <a:spcPts val="200"/>
-              </a:spcAft>
-              <a:defRPr sz="1400" b="1" i="0">
-                <a:solidFill>
-                  <a:srgbClr val="FFFFFF"/>
+              <a:t>Configuration (6 Layers)</a:t>
+            </a:r>
+          </a:p>
+          <a:p>
+            <a:pPr>
+              <a:lnSpc>
+                <a:spcPct val="115000"/>
+              </a:lnSpc>
+              <a:spcAft>
+                <a:spcPts val="600"/>
+              </a:spcAft>
+              <a:defRPr sz="1300" b="0" i="0">
+                <a:solidFill>
+                  <a:srgbClr val="D1D5DB"/>
                 </a:solidFill>
                 <a:latin typeface="Calibri"/>
               </a:defRPr>
             </a:pPr>
             <a:r>
-              <a:t>• Setup A: Baseline Network (No BN)</a:t>
-            </a:r>
-          </a:p>
-          <a:p>
-            <a:pPr>
-              <a:lnSpc>
-                <a:spcPct val="115000"/>
-              </a:lnSpc>
-              <a:spcAft>
-                <a:spcPts val="1600"/>
+              <a:t>• Input Layer:</a:t>
+            </a:r>
+            <a:br/>
+            <a:r>
+              <a:t>  784 nodes (flattened 28x28 pixels).</a:t>
+            </a:r>
+            <a:br/>
+            <a:br/>
+            <a:r>
+              <a:t>• Hidden Layers:</a:t>
+            </a:r>
+            <a:br/>
+            <a:r>
+              <a:t>  5 layers with 512 nodes each.</a:t>
+            </a:r>
+            <a:br/>
+            <a:br/>
+            <a:r>
+              <a:t>• Output Layer:</a:t>
+            </a:r>
+            <a:br/>
+            <a:r>
+              <a:t>  10 nodes (digit category scores).</a:t>
+            </a:r>
+            <a:br/>
+            <a:br/>
+            <a:r>
+              <a:t>• Activation:</a:t>
+            </a:r>
+            <a:br/>
+            <a:r>
+              <a:t>  ReLU in all hidden layers.</a:t>
+            </a:r>
+          </a:p>
+        </p:txBody>
+      </p:sp>
+      <p:sp>
+        <p:nvSpPr>
+          <p:cNvPr id="8" name="Rounded Rectangle 7"/>
+          <p:cNvSpPr/>
+          <p:nvPr/>
+        </p:nvSpPr>
+        <p:spPr>
+          <a:xfrm>
+            <a:off x="8076895" y="1463040"/>
+            <a:ext cx="3383280" cy="4572000"/>
+          </a:xfrm>
+          <a:prstGeom prst="roundRect">
+            <a:avLst/>
+          </a:prstGeom>
+          <a:solidFill>
+            <a:srgbClr val="141B2D"/>
+          </a:solidFill>
+          <a:ln w="19050">
+            <a:solidFill>
+              <a:srgbClr val="28324B"/>
+            </a:solidFill>
+          </a:ln>
+        </p:spPr>
+        <p:style>
+          <a:lnRef idx="1">
+            <a:schemeClr val="accent1"/>
+          </a:lnRef>
+          <a:fillRef idx="3">
+            <a:schemeClr val="accent1"/>
+          </a:fillRef>
+          <a:effectRef idx="2">
+            <a:schemeClr val="accent1"/>
+          </a:effectRef>
+          <a:fontRef idx="minor">
+            <a:schemeClr val="lt1"/>
+          </a:fontRef>
+        </p:style>
+        <p:txBody>
+          <a:bodyPr rtlCol="0" anchor="ctr"/>
+          <a:lstStyle/>
+          <a:p>
+            <a:pPr algn="ctr"/>
+          </a:p>
+        </p:txBody>
+      </p:sp>
+      <p:sp>
+        <p:nvSpPr>
+          <p:cNvPr id="9" name="TextBox 8"/>
+          <p:cNvSpPr txBox="1"/>
+          <p:nvPr/>
+        </p:nvSpPr>
+        <p:spPr>
+          <a:xfrm>
+            <a:off x="8259775" y="1645920"/>
+            <a:ext cx="3017520" cy="4206240"/>
+          </a:xfrm>
+          <a:prstGeom prst="rect">
+            <a:avLst/>
+          </a:prstGeom>
+          <a:noFill/>
+        </p:spPr>
+        <p:txBody>
+          <a:bodyPr wrap="square">
+            <a:spAutoFit/>
+          </a:bodyPr>
+          <a:lstStyle/>
+          <a:p>
+            <a:pPr>
+              <a:lnSpc>
+                <a:spcPct val="115000"/>
+              </a:lnSpc>
+              <a:spcAft>
+                <a:spcPts val="1200"/>
+              </a:spcAft>
+              <a:defRPr sz="1600" b="1" i="0">
+                <a:solidFill>
+                  <a:srgbClr val="FBBF24"/>
+                </a:solidFill>
+                <a:latin typeface="Georgia"/>
+              </a:defRPr>
+            </a:pPr>
+            <a:r>
+              <a:t>Tested Setups</a:t>
+            </a:r>
+          </a:p>
+          <a:p>
+            <a:pPr>
+              <a:lnSpc>
+                <a:spcPct val="115000"/>
+              </a:lnSpc>
+              <a:spcAft>
+                <a:spcPts val="600"/>
               </a:spcAft>
               <a:defRPr sz="1300" b="0" i="0">
                 <a:solidFill>
@@ -9558,83 +9643,29 @@
               </a:defRPr>
             </a:pPr>
             <a:r>
-              <a:t>  - Fully Connected (Linear) -&gt; ReLU Activation.</a:t>
-            </a:r>
-          </a:p>
-          <a:p>
-            <a:pPr>
-              <a:lnSpc>
-                <a:spcPct val="115000"/>
-              </a:lnSpc>
-              <a:spcAft>
-                <a:spcPts val="200"/>
-              </a:spcAft>
-              <a:defRPr sz="1400" b="1" i="0">
-                <a:solidFill>
-                  <a:srgbClr val="FFFFFF"/>
-                </a:solidFill>
-                <a:latin typeface="Calibri"/>
-              </a:defRPr>
-            </a:pPr>
-            <a:r>
-              <a:t>• Setup B: Normalized Network (With BN)</a:t>
-            </a:r>
-          </a:p>
-          <a:p>
-            <a:pPr>
-              <a:lnSpc>
-                <a:spcPct val="115000"/>
-              </a:lnSpc>
-              <a:spcAft>
-                <a:spcPts val="1600"/>
-              </a:spcAft>
-              <a:defRPr sz="1300" b="0" i="0">
-                <a:solidFill>
-                  <a:srgbClr val="D1D5DB"/>
-                </a:solidFill>
-                <a:latin typeface="Calibri"/>
-              </a:defRPr>
-            </a:pPr>
-            <a:r>
-              <a:t>  - Fully Connected -&gt; BatchNorm1d -&gt; ReLU Activation.</a:t>
-            </a:r>
-          </a:p>
-          <a:p>
-            <a:pPr>
-              <a:lnSpc>
-                <a:spcPct val="115000"/>
-              </a:lnSpc>
-              <a:spcAft>
-                <a:spcPts val="200"/>
-              </a:spcAft>
-              <a:defRPr sz="1400" b="1" i="0">
-                <a:solidFill>
-                  <a:srgbClr val="FFFFFF"/>
-                </a:solidFill>
-                <a:latin typeface="Calibri"/>
-              </a:defRPr>
-            </a:pPr>
-            <a:r>
-              <a:t>• Optimization settings:</a:t>
-            </a:r>
-          </a:p>
-          <a:p>
-            <a:pPr>
-              <a:lnSpc>
-                <a:spcPct val="115000"/>
-              </a:lnSpc>
-              <a:spcAft>
-                <a:spcPts val="600"/>
-              </a:spcAft>
-              <a:defRPr sz="1300" b="0" i="0">
-                <a:solidFill>
-                  <a:srgbClr val="D1D5DB"/>
-                </a:solidFill>
-                <a:latin typeface="Calibri"/>
-              </a:defRPr>
-            </a:pPr>
-            <a:r>
-              <a:t>  - Trained both setups using standard Mini-batch Stochastic Gradient Descent (SGD) with batch size of 64.</a:t>
+              <a:t>• Setup A (Baseline):</a:t>
+            </a:r>
+            <a:br/>
+            <a:r>
+              <a:t>  Standard MLP with Linear -&gt; ReLU layers. No batch normalization.</a:t>
+            </a:r>
+            <a:br/>
+            <a:br/>
+            <a:r>
+              <a:t>• Setup B (Batch Norm):</a:t>
+            </a:r>
+            <a:br/>
+            <a:r>
+              <a:t>  Normalized MLP with Linear -&gt; BatchNorm1d -&gt; ReLU layers.</a:t>
+            </a:r>
+            <a:br/>
+            <a:br/>
+            <a:r>
+              <a:t>• Optimization:</a:t>
+            </a:r>
+            <a:br/>
+            <a:r>
+              <a:t>  Mini-batch SGD with batch size = 64.</a:t>
             </a:r>
           </a:p>
         </p:txBody>
@@ -9902,7 +9933,7 @@
               </a:defRPr>
             </a:pPr>
             <a:r>
-              <a:t>  - With Batch Norm: Converges much faster, reaching 97.10% test accuracy.</a:t>
+              <a:t>  - With Batch Norm: Converges rapidly, reaching 97.10% test accuracy.</a:t>
             </a:r>
           </a:p>
           <a:p>

</xml_diff>